<commit_message>
fix: update eda presentation slides
</commit_message>
<xml_diff>
--- a/presentation/IBM_Attrition_EDA_Team_Presentation.pptx
+++ b/presentation/IBM_Attrition_EDA_Team_Presentation.pptx
@@ -1,35 +1,35 @@
 
 <file path=ppt/presentation.xml><?xml version="1.0" encoding="utf-8"?>
-<p:presentation xmlns:a="http://schemas.openxmlformats.org/drawingml/2006/main" xmlns:r="http://schemas.openxmlformats.org/officeDocument/2006/relationships" xmlns:p="http://schemas.openxmlformats.org/presentationml/2006/main" xmlns:m="http://schemas.openxmlformats.org/officeDocument/2006/math" xmlns:w="http://schemas.openxmlformats.org/wordprocessingml/2006/main" autoCompressPictures="0" saveSubsetFonts="1">
+<p:presentation xmlns:a="http://schemas.openxmlformats.org/drawingml/2006/main" xmlns:r="http://schemas.openxmlformats.org/officeDocument/2006/relationships" xmlns:p="http://schemas.openxmlformats.org/presentationml/2006/main" saveSubsetFonts="1" autoCompressPictures="0">
   <p:sldMasterIdLst>
     <p:sldMasterId id="2147483648" r:id="rId1"/>
   </p:sldMasterIdLst>
   <p:notesMasterIdLst>
-    <p:notesMasterId r:id="rId26"/>
+    <p:notesMasterId r:id="rId24"/>
   </p:notesMasterIdLst>
   <p:sldIdLst>
-    <p:sldId id="256" r:id="rId4"/>
-    <p:sldId id="257" r:id="rId5"/>
-    <p:sldId id="258" r:id="rId6"/>
-    <p:sldId id="259" r:id="rId7"/>
-    <p:sldId id="260" r:id="rId8"/>
-    <p:sldId id="261" r:id="rId9"/>
-    <p:sldId id="262" r:id="rId10"/>
-    <p:sldId id="263" r:id="rId11"/>
-    <p:sldId id="264" r:id="rId12"/>
-    <p:sldId id="265" r:id="rId13"/>
-    <p:sldId id="266" r:id="rId14"/>
-    <p:sldId id="267" r:id="rId15"/>
-    <p:sldId id="268" r:id="rId16"/>
-    <p:sldId id="269" r:id="rId17"/>
-    <p:sldId id="270" r:id="rId18"/>
-    <p:sldId id="271" r:id="rId19"/>
-    <p:sldId id="272" r:id="rId20"/>
-    <p:sldId id="273" r:id="rId21"/>
-    <p:sldId id="274" r:id="rId22"/>
-    <p:sldId id="275" r:id="rId23"/>
-    <p:sldId id="276" r:id="rId24"/>
-    <p:sldId id="277" r:id="rId25"/>
+    <p:sldId id="256" r:id="rId2"/>
+    <p:sldId id="257" r:id="rId3"/>
+    <p:sldId id="258" r:id="rId4"/>
+    <p:sldId id="259" r:id="rId5"/>
+    <p:sldId id="260" r:id="rId6"/>
+    <p:sldId id="261" r:id="rId7"/>
+    <p:sldId id="262" r:id="rId8"/>
+    <p:sldId id="263" r:id="rId9"/>
+    <p:sldId id="264" r:id="rId10"/>
+    <p:sldId id="265" r:id="rId11"/>
+    <p:sldId id="266" r:id="rId12"/>
+    <p:sldId id="267" r:id="rId13"/>
+    <p:sldId id="268" r:id="rId14"/>
+    <p:sldId id="269" r:id="rId15"/>
+    <p:sldId id="270" r:id="rId16"/>
+    <p:sldId id="271" r:id="rId17"/>
+    <p:sldId id="272" r:id="rId18"/>
+    <p:sldId id="273" r:id="rId19"/>
+    <p:sldId id="274" r:id="rId20"/>
+    <p:sldId id="275" r:id="rId21"/>
+    <p:sldId id="276" r:id="rId22"/>
+    <p:sldId id="277" r:id="rId23"/>
   </p:sldIdLst>
   <p:sldSz cx="12192000" cy="6858000"/>
   <p:notesSz cx="6858000" cy="9144000"/>
@@ -128,12 +128,36 @@
       </a:defRPr>
     </a:lvl9pPr>
   </p:defaultTextStyle>
+  <p:extLst>
+    <p:ext uri="{EFAFB233-063F-42B5-8137-9DF3F51BA10A}">
+      <p15:sldGuideLst xmlns:p15="http://schemas.microsoft.com/office/powerpoint/2012/main">
+        <p15:guide id="1" orient="horz" pos="2160">
+          <p15:clr>
+            <a:srgbClr val="A4A3A4"/>
+          </p15:clr>
+        </p15:guide>
+        <p15:guide id="2" pos="2880">
+          <p15:clr>
+            <a:srgbClr val="A4A3A4"/>
+          </p15:clr>
+        </p15:guide>
+      </p15:sldGuideLst>
+    </p:ext>
+  </p:extLst>
 </p:presentation>
+</file>
+
+<file path=ppt/revisionInfo.xml><?xml version="1.0" encoding="utf-8"?>
+<p1510:revInfo xmlns:a="http://schemas.openxmlformats.org/drawingml/2006/main" xmlns:r="http://schemas.openxmlformats.org/officeDocument/2006/relationships" xmlns:p1510="http://schemas.microsoft.com/office/powerpoint/2015/10/main">
+  <p1510:revLst>
+    <p1510:client id="{25AF352F-78E8-A7B2-D441-3A6560AEB68A}" v="73" dt="2026-09-13T21:43:53.342"/>
+  </p1510:revLst>
+</p1510:revInfo>
 </file>
 
 <file path=ppt/notesMasters/notesMaster1.xml><?xml version="1.0" encoding="utf-8"?>
 <p:notesMaster xmlns:a="http://schemas.openxmlformats.org/drawingml/2006/main" xmlns:r="http://schemas.openxmlformats.org/officeDocument/2006/relationships" xmlns:p="http://schemas.openxmlformats.org/presentationml/2006/main">
-  <p:cSld name="">
+  <p:cSld>
     <p:bg>
       <p:bgRef idx="1001">
         <a:schemeClr val="bg1"/>
@@ -252,8 +276,8 @@
 </file>
 
 <file path=ppt/notesSlides/notesSlide1.xml><?xml version="1.0" encoding="utf-8"?>
-<p:notes xmlns:a="http://schemas.openxmlformats.org/drawingml/2006/main" xmlns:r="http://schemas.openxmlformats.org/officeDocument/2006/relationships" xmlns:p="http://schemas.openxmlformats.org/presentationml/2006/main" xmlns:m="http://schemas.openxmlformats.org/officeDocument/2006/math" xmlns:w="http://schemas.openxmlformats.org/wordprocessingml/2006/main">
-  <p:cSld name="">
+<p:notes xmlns:a="http://schemas.openxmlformats.org/drawingml/2006/main" xmlns:r="http://schemas.openxmlformats.org/officeDocument/2006/relationships" xmlns:p="http://schemas.openxmlformats.org/presentationml/2006/main">
+  <p:cSld>
     <p:spTree>
       <p:nvGrpSpPr>
         <p:cNvPr id="1" name=""/>
@@ -272,7 +296,7 @@
         <p:nvSpPr>
           <p:cNvPr id="454542511" name="Slide Image Placeholder 1"/>
           <p:cNvSpPr>
-            <a:spLocks noChangeAspect="1" noGrp="1" noRot="1"/>
+            <a:spLocks noGrp="1" noRot="1" noChangeAspect="1"/>
           </p:cNvSpPr>
           <p:nvPr>
             <p:ph type="sldImg" idx="2"/>
@@ -299,10 +323,8 @@
               <a:defRPr/>
             </a:pPr>
             <a:r>
-              <a:rPr/>
               <a:t>Open: this is a diagnostic exploratory analysis of IBM's HR Analytics dataset — 1,470 employee records, 35 attributes, 16.1% overall attrition. Eleven notebooks, eight contributors, run in numeric order. Say up front: the dataset is fictional — IBM authored it as a teaching set, so every finding is a statement about this data and about our method, not an HR benchmark. Hand off to the introduction.</a:t>
             </a:r>
-            <a:endParaRPr/>
           </a:p>
         </p:txBody>
       </p:sp>
@@ -327,8 +349,8 @@
 </file>
 
 <file path=ppt/notesSlides/notesSlide10.xml><?xml version="1.0" encoding="utf-8"?>
-<p:notes xmlns:a="http://schemas.openxmlformats.org/drawingml/2006/main" xmlns:r="http://schemas.openxmlformats.org/officeDocument/2006/relationships" xmlns:p="http://schemas.openxmlformats.org/presentationml/2006/main" xmlns:m="http://schemas.openxmlformats.org/officeDocument/2006/math" xmlns:w="http://schemas.openxmlformats.org/wordprocessingml/2006/main">
-  <p:cSld name="">
+<p:notes xmlns:a="http://schemas.openxmlformats.org/drawingml/2006/main" xmlns:r="http://schemas.openxmlformats.org/officeDocument/2006/relationships" xmlns:p="http://schemas.openxmlformats.org/presentationml/2006/main">
+  <p:cSld>
     <p:spTree>
       <p:nvGrpSpPr>
         <p:cNvPr id="1" name=""/>
@@ -347,7 +369,7 @@
         <p:nvSpPr>
           <p:cNvPr id="1248570688" name="Slide Image Placeholder 1"/>
           <p:cNvSpPr>
-            <a:spLocks noChangeAspect="1" noGrp="1" noRot="1"/>
+            <a:spLocks noGrp="1" noRot="1" noChangeAspect="1"/>
           </p:cNvSpPr>
           <p:nvPr>
             <p:ph type="sldImg" idx="2"/>
@@ -374,10 +396,8 @@
               <a:defRPr/>
             </a:pPr>
             <a:r>
-              <a:rPr/>
               <a:t>This is the most robust finding in the deck because four separate measures agree. Company tenure 0–2 years: 29.8%. Years in current role 0–1: 27.9%. Years with current manager 0–1: 28.3%. Total career experience 0–2 years: 43.9%, which is 2.7 times baseline. The year-by-year line is worth pointing at: 36.4% in year zero, 34.5% in year one, then it crosses below the baseline by year three and stays there. The bumps at years 4 and 10 are small-sample noise, which is why we suppressed years with fewer than ten employees. What we cannot say: whether people leave because they are new, or whether the roles that hire heavily are also the roles people leave. Answering the question the README asked — early-tenure or mid-career — the evidence points clearly at early-tenure.</a:t>
             </a:r>
-            <a:endParaRPr/>
           </a:p>
         </p:txBody>
       </p:sp>
@@ -402,8 +422,8 @@
 </file>
 
 <file path=ppt/notesSlides/notesSlide11.xml><?xml version="1.0" encoding="utf-8"?>
-<p:notes xmlns:a="http://schemas.openxmlformats.org/drawingml/2006/main" xmlns:r="http://schemas.openxmlformats.org/officeDocument/2006/relationships" xmlns:p="http://schemas.openxmlformats.org/presentationml/2006/main" xmlns:m="http://schemas.openxmlformats.org/officeDocument/2006/math" xmlns:w="http://schemas.openxmlformats.org/wordprocessingml/2006/main">
-  <p:cSld name="">
+<p:notes xmlns:a="http://schemas.openxmlformats.org/drawingml/2006/main" xmlns:r="http://schemas.openxmlformats.org/officeDocument/2006/relationships" xmlns:p="http://schemas.openxmlformats.org/presentationml/2006/main">
+  <p:cSld>
     <p:spTree>
       <p:nvGrpSpPr>
         <p:cNvPr id="1" name=""/>
@@ -422,7 +442,7 @@
         <p:nvSpPr>
           <p:cNvPr id="1605607533" name="Slide Image Placeholder 1"/>
           <p:cNvSpPr>
-            <a:spLocks noChangeAspect="1" noGrp="1" noRot="1"/>
+            <a:spLocks noGrp="1" noRot="1" noChangeAspect="1"/>
           </p:cNvSpPr>
           <p:nvPr>
             <p:ph type="sldImg" idx="2"/>
@@ -449,10 +469,8 @@
               <a:defRPr/>
             </a:pPr>
             <a:r>
-              <a:rPr/>
               <a:t>Twenty-three individual distribution figures in the notebook — we are showing the method, not all of them. The design decision worth calling out is the split treatment: continuous columns get a histogram, columns with ten or fewer distinct values get value-count bars. That matters because a KDE over a 1–4 satisfaction scale invents a shape that is not in the data. The substantive finding is the right skew in income, tenure and experience, and it drives three later decisions: median over mean, the volume of IQR flags in step 07, and banded rather than mean-based comparisons throughout. Transition: so what did the IQR rule flag?</a:t>
             </a:r>
-            <a:endParaRPr/>
           </a:p>
         </p:txBody>
       </p:sp>
@@ -477,8 +495,8 @@
 </file>
 
 <file path=ppt/notesSlides/notesSlide12.xml><?xml version="1.0" encoding="utf-8"?>
-<p:notes xmlns:a="http://schemas.openxmlformats.org/drawingml/2006/main" xmlns:r="http://schemas.openxmlformats.org/officeDocument/2006/relationships" xmlns:p="http://schemas.openxmlformats.org/presentationml/2006/main" xmlns:m="http://schemas.openxmlformats.org/officeDocument/2006/math" xmlns:w="http://schemas.openxmlformats.org/wordprocessingml/2006/main">
-  <p:cSld name="">
+<p:notes xmlns:a="http://schemas.openxmlformats.org/drawingml/2006/main" xmlns:r="http://schemas.openxmlformats.org/officeDocument/2006/relationships" xmlns:p="http://schemas.openxmlformats.org/presentationml/2006/main">
+  <p:cSld>
     <p:spTree>
       <p:nvGrpSpPr>
         <p:cNvPr id="1" name=""/>
@@ -497,7 +515,7 @@
         <p:nvSpPr>
           <p:cNvPr id="1522169822" name="Slide Image Placeholder 1"/>
           <p:cNvSpPr>
-            <a:spLocks noChangeAspect="1" noGrp="1" noRot="1"/>
+            <a:spLocks noGrp="1" noRot="1" noChangeAspect="1"/>
           </p:cNvSpPr>
           <p:nvPr>
             <p:ph type="sldImg" idx="2"/>
@@ -524,10 +542,8 @@
               <a:defRPr/>
             </a:pPr>
             <a:r>
-              <a:rPr/>
               <a:t>The interesting result here is a decision, not a number. The IQR rule flagged 238 TrainingTimesLastYear values (16.19%) and 114 MonthlyIncome values (7.76%), but inspection showed both are artefacts of the rule rather than problems in the data. For income, every single one of the 114 is above the fence and every one is a senior manager or research director with two to three decades of experience — real people, not typos. For training, the variable has a one-unit interquartile range, so the fence lands at 4.5 and anyone attending five sessions is an 'outlier'. That is the rule misfiring on a discrete variable. So everything was retained. If asked why that is the right call: those senior employees have the lowest attrition rates in the dataset — deleting them would remove the contrast the whole analysis rests on.</a:t>
             </a:r>
-            <a:endParaRPr/>
           </a:p>
         </p:txBody>
       </p:sp>
@@ -552,8 +568,8 @@
 </file>
 
 <file path=ppt/notesSlides/notesSlide13.xml><?xml version="1.0" encoding="utf-8"?>
-<p:notes xmlns:a="http://schemas.openxmlformats.org/drawingml/2006/main" xmlns:r="http://schemas.openxmlformats.org/officeDocument/2006/relationships" xmlns:p="http://schemas.openxmlformats.org/presentationml/2006/main" xmlns:m="http://schemas.openxmlformats.org/officeDocument/2006/math" xmlns:w="http://schemas.openxmlformats.org/wordprocessingml/2006/main">
-  <p:cSld name="">
+<p:notes xmlns:a="http://schemas.openxmlformats.org/drawingml/2006/main" xmlns:r="http://schemas.openxmlformats.org/officeDocument/2006/relationships" xmlns:p="http://schemas.openxmlformats.org/presentationml/2006/main">
+  <p:cSld>
     <p:spTree>
       <p:nvGrpSpPr>
         <p:cNvPr id="1" name=""/>
@@ -572,7 +588,7 @@
         <p:nvSpPr>
           <p:cNvPr id="1045982768" name="Slide Image Placeholder 1"/>
           <p:cNvSpPr>
-            <a:spLocks noChangeAspect="1" noGrp="1" noRot="1"/>
+            <a:spLocks noGrp="1" noRot="1" noChangeAspect="1"/>
           </p:cNvSpPr>
           <p:nvPr>
             <p:ph type="sldImg" idx="2"/>
@@ -599,10 +615,8 @@
               <a:defRPr/>
             </a:pPr>
             <a:r>
-              <a:rPr/>
               <a:t>Two charts, one lesson. On the left, the twelve biggest group gaps among segments of at least fifty people — and overtime is the standout because it is both a large gap and a large group: 416 employees, 30.5% versus 10.4%. On the right, every numeric correlation with leaving, and the strongest is total working years at minus 0.171. That is a weak correlation by any standard. Make the methodological point clearly, because it is the most sophisticated thing in the deck: a Pearson coefficient against a 0/1 outcome is answering a different and less useful question than 'what share of this group left'. The notebook's own comment says to treat these as screening signals, not causal explanations, and we agree. Also note the direction: almost every correlation is negative — more of anything (tenure, level, income, age, satisfaction) travels with staying. Distance from home at plus 0.078 is the only meaningful positive.</a:t>
             </a:r>
-            <a:endParaRPr/>
           </a:p>
         </p:txBody>
       </p:sp>
@@ -627,8 +641,8 @@
 </file>
 
 <file path=ppt/notesSlides/notesSlide14.xml><?xml version="1.0" encoding="utf-8"?>
-<p:notes xmlns:a="http://schemas.openxmlformats.org/drawingml/2006/main" xmlns:r="http://schemas.openxmlformats.org/officeDocument/2006/relationships" xmlns:p="http://schemas.openxmlformats.org/presentationml/2006/main" xmlns:m="http://schemas.openxmlformats.org/officeDocument/2006/math" xmlns:w="http://schemas.openxmlformats.org/wordprocessingml/2006/main">
-  <p:cSld name="">
+<p:notes xmlns:a="http://schemas.openxmlformats.org/drawingml/2006/main" xmlns:r="http://schemas.openxmlformats.org/officeDocument/2006/relationships" xmlns:p="http://schemas.openxmlformats.org/presentationml/2006/main">
+  <p:cSld>
     <p:spTree>
       <p:nvGrpSpPr>
         <p:cNvPr id="1" name=""/>
@@ -647,7 +661,7 @@
         <p:nvSpPr>
           <p:cNvPr id="1792653021" name="Slide Image Placeholder 1"/>
           <p:cNvSpPr>
-            <a:spLocks noChangeAspect="1" noGrp="1" noRot="1"/>
+            <a:spLocks noGrp="1" noRot="1" noChangeAspect="1"/>
           </p:cNvSpPr>
           <p:nvPr>
             <p:ph type="sldImg" idx="2"/>
@@ -674,10 +688,8 @@
               <a:defRPr/>
             </a:pPr>
             <a:r>
-              <a:rPr/>
               <a:t>Short slide — it is context, not a finding about attrition, and the notebook says so itself in its closing line. Numbers to have ready: income mean $6,503 versus median $4,919; tenure mean 7 versus median 5; experience mean 11.3 versus median 10. In all three the mean sits above the median, which is the signature of a right skew. The one bridge back to the main story is in the conclusion box: the bulk of the workforce lives in the same low-tenure, lower-paid, entry-level region we flagged as high risk, so those segments are big as well as risky. That is the reason the excess-attrition numbers were as large as they were.</a:t>
             </a:r>
-            <a:endParaRPr/>
           </a:p>
         </p:txBody>
       </p:sp>
@@ -702,8 +714,8 @@
 </file>
 
 <file path=ppt/notesSlides/notesSlide15.xml><?xml version="1.0" encoding="utf-8"?>
-<p:notes xmlns:a="http://schemas.openxmlformats.org/drawingml/2006/main" xmlns:r="http://schemas.openxmlformats.org/officeDocument/2006/relationships" xmlns:p="http://schemas.openxmlformats.org/presentationml/2006/main" xmlns:m="http://schemas.openxmlformats.org/officeDocument/2006/math" xmlns:w="http://schemas.openxmlformats.org/wordprocessingml/2006/main">
-  <p:cSld name="">
+<p:notes xmlns:a="http://schemas.openxmlformats.org/drawingml/2006/main" xmlns:r="http://schemas.openxmlformats.org/officeDocument/2006/relationships" xmlns:p="http://schemas.openxmlformats.org/presentationml/2006/main">
+  <p:cSld>
     <p:spTree>
       <p:nvGrpSpPr>
         <p:cNvPr id="1" name=""/>
@@ -722,7 +734,7 @@
         <p:nvSpPr>
           <p:cNvPr id="1515616501" name="Slide Image Placeholder 1"/>
           <p:cNvSpPr>
-            <a:spLocks noChangeAspect="1" noGrp="1" noRot="1"/>
+            <a:spLocks noGrp="1" noRot="1" noChangeAspect="1"/>
           </p:cNvSpPr>
           <p:nvPr>
             <p:ph type="sldImg" idx="2"/>
@@ -749,10 +761,8 @@
               <a:defRPr/>
             </a:pPr>
             <a:r>
-              <a:rPr/>
               <a:t>Handle this slide carefully, because the accuracy number invites the wrong conclusion. 86% accuracy sounds strong until you notice that predicting 'nobody leaves' would score 84% on a dataset that is 16% leavers. The honest read is in the confusion matrix: of 47 people who actually left, the model found 16 and missed 31. Recall of 34%. So as a screening tool it is weak. What it does do well is rank — ROC-AUC 0.811 means it usually puts a leaver above a stayer, and the notebook's probability output is more useful than its yes/no call. The coefficients are the real payoff: overtime plus 1.80 is the single largest weight, which independently corroborates the step 08 finding. Two caveats to volunteer: coefficient magnitudes are not comparable across feature types because only the 14 continuous columns were standardised; and this model is a check on the descriptive work, not a deployable risk score.</a:t>
             </a:r>
-            <a:endParaRPr/>
           </a:p>
         </p:txBody>
       </p:sp>
@@ -777,8 +787,8 @@
 </file>
 
 <file path=ppt/notesSlides/notesSlide16.xml><?xml version="1.0" encoding="utf-8"?>
-<p:notes xmlns:a="http://schemas.openxmlformats.org/drawingml/2006/main" xmlns:r="http://schemas.openxmlformats.org/officeDocument/2006/relationships" xmlns:p="http://schemas.openxmlformats.org/presentationml/2006/main" xmlns:m="http://schemas.openxmlformats.org/officeDocument/2006/math" xmlns:w="http://schemas.openxmlformats.org/wordprocessingml/2006/main">
-  <p:cSld name="">
+<p:notes xmlns:a="http://schemas.openxmlformats.org/drawingml/2006/main" xmlns:r="http://schemas.openxmlformats.org/officeDocument/2006/relationships" xmlns:p="http://schemas.openxmlformats.org/presentationml/2006/main">
+  <p:cSld>
     <p:spTree>
       <p:nvGrpSpPr>
         <p:cNvPr id="1" name=""/>
@@ -797,7 +807,7 @@
         <p:nvSpPr>
           <p:cNvPr id="2001115327" name="Slide Image Placeholder 1"/>
           <p:cNvSpPr>
-            <a:spLocks noChangeAspect="1" noGrp="1" noRot="1"/>
+            <a:spLocks noGrp="1" noRot="1" noChangeAspect="1"/>
           </p:cNvSpPr>
           <p:nvPr>
             <p:ph type="sldImg" idx="2"/>
@@ -824,10 +834,8 @@
               <a:defRPr/>
             </a:pPr>
             <a:r>
-              <a:rPr/>
               <a:t>This is the slide to slow down on. The ranking is by strength of evidence, not by size of the headline number — which is why Sales Representatives at 39.8% sit at number four rather than number one. Findings one to four are the ones we would defend; five and six are real but confounded or weak, and they are marked differently for that reason. If you take one thing away: early tenure, entry level and overtime, all on large segments, all corroborated by more than one method. Every statement here is 'associated with' — we have one snapshot of one fictional company and no experiment, so nothing here establishes cause.</a:t>
             </a:r>
-            <a:endParaRPr/>
           </a:p>
         </p:txBody>
       </p:sp>
@@ -852,8 +860,8 @@
 </file>
 
 <file path=ppt/notesSlides/notesSlide17.xml><?xml version="1.0" encoding="utf-8"?>
-<p:notes xmlns:a="http://schemas.openxmlformats.org/drawingml/2006/main" xmlns:r="http://schemas.openxmlformats.org/officeDocument/2006/relationships" xmlns:p="http://schemas.openxmlformats.org/presentationml/2006/main" xmlns:m="http://schemas.openxmlformats.org/officeDocument/2006/math" xmlns:w="http://schemas.openxmlformats.org/wordprocessingml/2006/main">
-  <p:cSld name="">
+<p:notes xmlns:a="http://schemas.openxmlformats.org/drawingml/2006/main" xmlns:r="http://schemas.openxmlformats.org/officeDocument/2006/relationships" xmlns:p="http://schemas.openxmlformats.org/presentationml/2006/main">
+  <p:cSld>
     <p:spTree>
       <p:nvGrpSpPr>
         <p:cNvPr id="1" name=""/>
@@ -872,7 +880,7 @@
         <p:nvSpPr>
           <p:cNvPr id="219703879" name="Slide Image Placeholder 1"/>
           <p:cNvSpPr>
-            <a:spLocks noChangeAspect="1" noGrp="1" noRot="1"/>
+            <a:spLocks noGrp="1" noRot="1" noChangeAspect="1"/>
           </p:cNvSpPr>
           <p:nvPr>
             <p:ph type="sldImg" idx="2"/>
@@ -899,10 +907,8 @@
               <a:defRPr/>
             </a:pPr>
             <a:r>
-              <a:rPr/>
               <a:t>Use this as the picture the audience takes home. The left panel is every above-baseline segment we measured, sorted by rate, with headcount attached. The right column is the mirror image — the profile associated with staying. The single most important caveat is the overlap box: these eleven rows are not eleven independent risk factors. A 26-year-old entry-level Sales Representative in their first year on the lowest pay quartile appears in five of them. Building a risk score by adding these up would double-count badly. Also repeat the ethics point: this is a segment-level description. The README is explicit that gender, age and marital status stay out of anything that scores an individual, and we will come back to that on the next slide.</a:t>
             </a:r>
-            <a:endParaRPr/>
           </a:p>
         </p:txBody>
       </p:sp>
@@ -927,8 +933,8 @@
 </file>
 
 <file path=ppt/notesSlides/notesSlide18.xml><?xml version="1.0" encoding="utf-8"?>
-<p:notes xmlns:a="http://schemas.openxmlformats.org/drawingml/2006/main" xmlns:r="http://schemas.openxmlformats.org/officeDocument/2006/relationships" xmlns:p="http://schemas.openxmlformats.org/presentationml/2006/main" xmlns:m="http://schemas.openxmlformats.org/officeDocument/2006/math" xmlns:w="http://schemas.openxmlformats.org/wordprocessingml/2006/main">
-  <p:cSld name="">
+<p:notes xmlns:a="http://schemas.openxmlformats.org/drawingml/2006/main" xmlns:r="http://schemas.openxmlformats.org/officeDocument/2006/relationships" xmlns:p="http://schemas.openxmlformats.org/presentationml/2006/main">
+  <p:cSld>
     <p:spTree>
       <p:nvGrpSpPr>
         <p:cNvPr id="1" name=""/>
@@ -947,7 +953,7 @@
         <p:nvSpPr>
           <p:cNvPr id="2008981740" name="Slide Image Placeholder 1"/>
           <p:cNvSpPr>
-            <a:spLocks noChangeAspect="1" noGrp="1" noRot="1"/>
+            <a:spLocks noGrp="1" noRot="1" noChangeAspect="1"/>
           </p:cNvSpPr>
           <p:nvPr>
             <p:ph type="sldImg" idx="2"/>
@@ -974,10 +980,8 @@
               <a:defRPr/>
             </a:pPr>
             <a:r>
-              <a:rPr/>
               <a:t>Left column is about the company, right column is about us. Two genuine surprises worth narrating. First, attrition is not a clean staircase down the hierarchy — level 3 leaves more than level 2, and level 5 more than level 4. With 218 and 69 people in those bands, some of that is noise, but it undercuts any simple 'seniority protects you' story. Second, years since last promotion looks like nothing on its own, a correlation of minus 0.033, yet it is a strong positive weight in the model — a reminder that a variable can be invisible alone and informative in combination. On the right, the most important admission is confounding: we never stratified, so we genuinely cannot say whether overtime matters independently of job level. And be upfront about the last one — our own README says protected attributes stay out of individual scoring, and the notebook 10 model includes age, gender and marital status. That is an inconsistency we should fix, not defend.</a:t>
             </a:r>
-            <a:endParaRPr/>
           </a:p>
         </p:txBody>
       </p:sp>
@@ -1002,8 +1006,8 @@
 </file>
 
 <file path=ppt/notesSlides/notesSlide19.xml><?xml version="1.0" encoding="utf-8"?>
-<p:notes xmlns:a="http://schemas.openxmlformats.org/drawingml/2006/main" xmlns:r="http://schemas.openxmlformats.org/officeDocument/2006/relationships" xmlns:p="http://schemas.openxmlformats.org/presentationml/2006/main" xmlns:m="http://schemas.openxmlformats.org/officeDocument/2006/math" xmlns:w="http://schemas.openxmlformats.org/wordprocessingml/2006/main">
-  <p:cSld name="">
+<p:notes xmlns:a="http://schemas.openxmlformats.org/drawingml/2006/main" xmlns:r="http://schemas.openxmlformats.org/officeDocument/2006/relationships" xmlns:p="http://schemas.openxmlformats.org/presentationml/2006/main">
+  <p:cSld>
     <p:spTree>
       <p:nvGrpSpPr>
         <p:cNvPr id="1" name=""/>
@@ -1022,7 +1026,7 @@
         <p:nvSpPr>
           <p:cNvPr id="574350481" name="Slide Image Placeholder 1"/>
           <p:cNvSpPr>
-            <a:spLocks noChangeAspect="1" noGrp="1" noRot="1"/>
+            <a:spLocks noGrp="1" noRot="1" noChangeAspect="1"/>
           </p:cNvSpPr>
           <p:nvPr>
             <p:ph type="sldImg" idx="2"/>
@@ -1049,10 +1053,8 @@
               <a:defRPr/>
             </a:pPr>
             <a:r>
-              <a:rPr/>
               <a:t>Keep this brief and let the tree do the work. Three things to say. One: the notebooks are numerically prefixed and committed with their outputs, so a reviewer can read the whole analysis on GitHub without running anything. Two: the team used actual branch-and-pull-request workflow with Conventional Commits, which is why we can attribute notebooks to people from the history rather than from memory. Three: the repository goes beyond notebooks — there is a Dash application over the same raw file that shares notebook 04's bin edges, so the app and the analysis cannot drift apart. If asked about the four contributors listed without a notebook: they are credited in the README author table, but the git history does not record notebook-level commits under those names, and we would rather say that than invent responsibilities.</a:t>
             </a:r>
-            <a:endParaRPr/>
           </a:p>
         </p:txBody>
       </p:sp>
@@ -1077,8 +1079,8 @@
 </file>
 
 <file path=ppt/notesSlides/notesSlide2.xml><?xml version="1.0" encoding="utf-8"?>
-<p:notes xmlns:a="http://schemas.openxmlformats.org/drawingml/2006/main" xmlns:r="http://schemas.openxmlformats.org/officeDocument/2006/relationships" xmlns:p="http://schemas.openxmlformats.org/presentationml/2006/main" xmlns:m="http://schemas.openxmlformats.org/officeDocument/2006/math" xmlns:w="http://schemas.openxmlformats.org/wordprocessingml/2006/main">
-  <p:cSld name="">
+<p:notes xmlns:a="http://schemas.openxmlformats.org/drawingml/2006/main" xmlns:r="http://schemas.openxmlformats.org/officeDocument/2006/relationships" xmlns:p="http://schemas.openxmlformats.org/presentationml/2006/main">
+  <p:cSld>
     <p:spTree>
       <p:nvGrpSpPr>
         <p:cNvPr id="1" name=""/>
@@ -1097,7 +1099,7 @@
         <p:nvSpPr>
           <p:cNvPr id="1405420763" name="Slide Image Placeholder 1"/>
           <p:cNvSpPr>
-            <a:spLocks noChangeAspect="1" noGrp="1" noRot="1"/>
+            <a:spLocks noGrp="1" noRot="1" noChangeAspect="1"/>
           </p:cNvSpPr>
           <p:nvPr>
             <p:ph type="sldImg" idx="2"/>
@@ -1124,10 +1126,8 @@
               <a:defRPr/>
             </a:pPr>
             <a:r>
-              <a:rPr/>
               <a:t>Frame the business problem before any numbers. The key sentence is the goal box: we are measuring over-representation, not causation. That constraint is a property of the data — one snapshot, no event timestamps, no control group — not modesty. The five question groups on the right are the README's own structure and they map onto the notebook sequence you are about to see. Note for honesty: the notebooks fully answer groups 1 and 2 and partially answer 3–5; we will say so again at the end.</a:t>
             </a:r>
-            <a:endParaRPr/>
           </a:p>
         </p:txBody>
       </p:sp>
@@ -1152,8 +1152,8 @@
 </file>
 
 <file path=ppt/notesSlides/notesSlide20.xml><?xml version="1.0" encoding="utf-8"?>
-<p:notes xmlns:a="http://schemas.openxmlformats.org/drawingml/2006/main" xmlns:r="http://schemas.openxmlformats.org/officeDocument/2006/relationships" xmlns:p="http://schemas.openxmlformats.org/presentationml/2006/main" xmlns:m="http://schemas.openxmlformats.org/officeDocument/2006/math" xmlns:w="http://schemas.openxmlformats.org/wordprocessingml/2006/main">
-  <p:cSld name="">
+<p:notes xmlns:a="http://schemas.openxmlformats.org/drawingml/2006/main" xmlns:r="http://schemas.openxmlformats.org/officeDocument/2006/relationships" xmlns:p="http://schemas.openxmlformats.org/presentationml/2006/main">
+  <p:cSld>
     <p:spTree>
       <p:nvGrpSpPr>
         <p:cNvPr id="1" name=""/>
@@ -1172,7 +1172,7 @@
         <p:nvSpPr>
           <p:cNvPr id="1484625121" name="Slide Image Placeholder 1"/>
           <p:cNvSpPr>
-            <a:spLocks noChangeAspect="1" noGrp="1" noRot="1"/>
+            <a:spLocks noGrp="1" noRot="1" noChangeAspect="1"/>
           </p:cNvSpPr>
           <p:nvPr>
             <p:ph type="sldImg" idx="2"/>
@@ -1199,10 +1199,8 @@
               <a:defRPr/>
             </a:pPr>
             <a:r>
-              <a:rPr/>
               <a:t>Do not read the grid aloud — point at the columns. The framing that matters: everything on this slide is evidenced in the repository, which is why Excel and Streamlit are called out at the bottom as listed in the README but absent from the code. If someone asks what the most transferable skill was, the honest answer is not a library — it is the excess-attrition calculation and knowing to print a headcount next to every rate. Two small things worth knowing: pandas Styler is how the notebooks format their summary tables for readability, and scikit-learn appears in two places, scaling in notebook 03 and the model in notebook 10.</a:t>
             </a:r>
-            <a:endParaRPr/>
           </a:p>
         </p:txBody>
       </p:sp>
@@ -1227,8 +1225,8 @@
 </file>
 
 <file path=ppt/notesSlides/notesSlide21.xml><?xml version="1.0" encoding="utf-8"?>
-<p:notes xmlns:a="http://schemas.openxmlformats.org/drawingml/2006/main" xmlns:r="http://schemas.openxmlformats.org/officeDocument/2006/relationships" xmlns:p="http://schemas.openxmlformats.org/presentationml/2006/main" xmlns:m="http://schemas.openxmlformats.org/officeDocument/2006/math" xmlns:w="http://schemas.openxmlformats.org/wordprocessingml/2006/main">
-  <p:cSld name="">
+<p:notes xmlns:a="http://schemas.openxmlformats.org/drawingml/2006/main" xmlns:r="http://schemas.openxmlformats.org/officeDocument/2006/relationships" xmlns:p="http://schemas.openxmlformats.org/presentationml/2006/main">
+  <p:cSld>
     <p:spTree>
       <p:nvGrpSpPr>
         <p:cNvPr id="1" name=""/>
@@ -1247,7 +1245,7 @@
         <p:nvSpPr>
           <p:cNvPr id="154965682" name="Slide Image Placeholder 1"/>
           <p:cNvSpPr>
-            <a:spLocks noChangeAspect="1" noGrp="1" noRot="1"/>
+            <a:spLocks noGrp="1" noRot="1" noChangeAspect="1"/>
           </p:cNvSpPr>
           <p:nvPr>
             <p:ph type="sldImg" idx="2"/>
@@ -1274,10 +1272,8 @@
               <a:defRPr/>
             </a:pPr>
             <a:r>
-              <a:rPr/>
               <a:t>Three columns, three different kinds of claim, and the distinction is the point. Left: what we measured. Middle: what a reader should do with it. Right: what we have not done — and predictive modelling belongs there, not in the findings, even though notebook 10 exists. If you have time for one next step, argue for stratification: until we know whether overtime still moves the rate inside a single level and tenure band, we cannot tell an HR team which lever to pull. Close on the red box: one snapshot, fictional data, associations only.</a:t>
             </a:r>
-            <a:endParaRPr/>
           </a:p>
         </p:txBody>
       </p:sp>
@@ -1302,8 +1298,8 @@
 </file>
 
 <file path=ppt/notesSlides/notesSlide22.xml><?xml version="1.0" encoding="utf-8"?>
-<p:notes xmlns:a="http://schemas.openxmlformats.org/drawingml/2006/main" xmlns:r="http://schemas.openxmlformats.org/officeDocument/2006/relationships" xmlns:p="http://schemas.openxmlformats.org/presentationml/2006/main" xmlns:m="http://schemas.openxmlformats.org/officeDocument/2006/math" xmlns:w="http://schemas.openxmlformats.org/wordprocessingml/2006/main">
-  <p:cSld name="">
+<p:notes xmlns:a="http://schemas.openxmlformats.org/drawingml/2006/main" xmlns:r="http://schemas.openxmlformats.org/officeDocument/2006/relationships" xmlns:p="http://schemas.openxmlformats.org/presentationml/2006/main">
+  <p:cSld>
     <p:spTree>
       <p:nvGrpSpPr>
         <p:cNvPr id="1" name=""/>
@@ -1322,7 +1318,7 @@
         <p:nvSpPr>
           <p:cNvPr id="1099263960" name="Slide Image Placeholder 1"/>
           <p:cNvSpPr>
-            <a:spLocks noChangeAspect="1" noGrp="1" noRot="1"/>
+            <a:spLocks noGrp="1" noRot="1" noChangeAspect="1"/>
           </p:cNvSpPr>
           <p:nvPr>
             <p:ph type="sldImg" idx="2"/>
@@ -1349,10 +1345,8 @@
               <a:defRPr/>
             </a:pPr>
             <a:r>
-              <a:rPr/>
               <a:t>Anticipated questions and the short answers. Why is accuracy 86% but the model weak? Because 84% comes free from predicting nobody leaves — look at recall, 34%. Why not just use the correlations? Because the strongest is minus 0.171; grouped rates are the interpretable view. Is Sales Representative really the worst role? Highest rate, yes, on 83 people — Laboratory Technicians tie it on excess departures with 259 people, and that is the more actionable number. Does overtime cause attrition? Unknown and unknowable from this data: one snapshot, no experiment, and we never controlled for job level. Can we predict who will leave? Not responsibly from this work — and the project's own ethics rules keep protected attributes out of individual scoring, which the current model does not yet respect.</a:t>
             </a:r>
-            <a:endParaRPr/>
           </a:p>
         </p:txBody>
       </p:sp>
@@ -1377,8 +1371,8 @@
 </file>
 
 <file path=ppt/notesSlides/notesSlide3.xml><?xml version="1.0" encoding="utf-8"?>
-<p:notes xmlns:a="http://schemas.openxmlformats.org/drawingml/2006/main" xmlns:r="http://schemas.openxmlformats.org/officeDocument/2006/relationships" xmlns:p="http://schemas.openxmlformats.org/presentationml/2006/main" xmlns:m="http://schemas.openxmlformats.org/officeDocument/2006/math" xmlns:w="http://schemas.openxmlformats.org/wordprocessingml/2006/main">
-  <p:cSld name="">
+<p:notes xmlns:a="http://schemas.openxmlformats.org/drawingml/2006/main" xmlns:r="http://schemas.openxmlformats.org/officeDocument/2006/relationships" xmlns:p="http://schemas.openxmlformats.org/presentationml/2006/main">
+  <p:cSld>
     <p:spTree>
       <p:nvGrpSpPr>
         <p:cNvPr id="1" name=""/>
@@ -1397,7 +1391,7 @@
         <p:nvSpPr>
           <p:cNvPr id="42154661" name="Slide Image Placeholder 1"/>
           <p:cNvSpPr>
-            <a:spLocks noChangeAspect="1" noGrp="1" noRot="1"/>
+            <a:spLocks noGrp="1" noRot="1" noChangeAspect="1"/>
           </p:cNvSpPr>
           <p:nvPr>
             <p:ph type="sldImg" idx="2"/>
@@ -1424,10 +1418,8 @@
               <a:defRPr/>
             </a:pPr>
             <a:r>
-              <a:rPr/>
               <a:t>Hit the four cards and move on: 1,470 records, 35 columns, 16.1% baseline, zero missing values. The 16.1% is 237 of 1,470 — that number becomes the reference line on nearly every chart from here on. Two things worth pausing on: the grain is a single snapshot with no dates, which is why we can never speak about sequence or cause; and the class imbalance, 237 versus 1,233, which is why we always print the segment headcount next to the rate — a 40% rate on 83 people is a different claim than a 40% rate on 800. Transition: here is the order we worked in.</a:t>
             </a:r>
-            <a:endParaRPr/>
           </a:p>
         </p:txBody>
       </p:sp>
@@ -1452,8 +1444,8 @@
 </file>
 
 <file path=ppt/notesSlides/notesSlide4.xml><?xml version="1.0" encoding="utf-8"?>
-<p:notes xmlns:a="http://schemas.openxmlformats.org/drawingml/2006/main" xmlns:r="http://schemas.openxmlformats.org/officeDocument/2006/relationships" xmlns:p="http://schemas.openxmlformats.org/presentationml/2006/main" xmlns:m="http://schemas.openxmlformats.org/officeDocument/2006/math" xmlns:w="http://schemas.openxmlformats.org/wordprocessingml/2006/main">
-  <p:cSld name="">
+<p:notes xmlns:a="http://schemas.openxmlformats.org/drawingml/2006/main" xmlns:r="http://schemas.openxmlformats.org/officeDocument/2006/relationships" xmlns:p="http://schemas.openxmlformats.org/presentationml/2006/main">
+  <p:cSld>
     <p:spTree>
       <p:nvGrpSpPr>
         <p:cNvPr id="1" name=""/>
@@ -1472,7 +1464,7 @@
         <p:nvSpPr>
           <p:cNvPr id="401907553" name="Slide Image Placeholder 1"/>
           <p:cNvSpPr>
-            <a:spLocks noChangeAspect="1" noGrp="1" noRot="1"/>
+            <a:spLocks noGrp="1" noRot="1" noChangeAspect="1"/>
           </p:cNvSpPr>
           <p:nvPr>
             <p:ph type="sldImg" idx="2"/>
@@ -1499,10 +1491,8 @@
               <a:defRPr/>
             </a:pPr>
             <a:r>
-              <a:rPr/>
               <a:t>This is the actual notebook sequence, not an idealised pipeline. Two points to make. First, every notebook re-reads data/raw rather than chaining off the previous one — that keeps each step independently reproducible, at the cost of re-deriving the same bins in a few places. Second, the four measures at the bottom are the vocabulary for the rest of the deck. Spend your time on excess attrition: it is the one that stops a 23% rate on 52 people from being mistaken for the company's biggest retention problem. Notebook 10 is greyed because it is a predictive check, deliberately outside the diagnostic frame.</a:t>
             </a:r>
-            <a:endParaRPr/>
           </a:p>
         </p:txBody>
       </p:sp>
@@ -1527,8 +1517,8 @@
 </file>
 
 <file path=ppt/notesSlides/notesSlide5.xml><?xml version="1.0" encoding="utf-8"?>
-<p:notes xmlns:a="http://schemas.openxmlformats.org/drawingml/2006/main" xmlns:r="http://schemas.openxmlformats.org/officeDocument/2006/relationships" xmlns:p="http://schemas.openxmlformats.org/presentationml/2006/main" xmlns:m="http://schemas.openxmlformats.org/officeDocument/2006/math" xmlns:w="http://schemas.openxmlformats.org/wordprocessingml/2006/main">
-  <p:cSld name="">
+<p:notes xmlns:a="http://schemas.openxmlformats.org/drawingml/2006/main" xmlns:r="http://schemas.openxmlformats.org/officeDocument/2006/relationships" xmlns:p="http://schemas.openxmlformats.org/presentationml/2006/main">
+  <p:cSld>
     <p:spTree>
       <p:nvGrpSpPr>
         <p:cNvPr id="1" name=""/>
@@ -1547,7 +1537,7 @@
         <p:nvSpPr>
           <p:cNvPr id="1132242693" name="Slide Image Placeholder 1"/>
           <p:cNvSpPr>
-            <a:spLocks noChangeAspect="1" noGrp="1" noRot="1"/>
+            <a:spLocks noGrp="1" noRot="1" noChangeAspect="1"/>
           </p:cNvSpPr>
           <p:nvPr>
             <p:ph type="sldImg" idx="2"/>
@@ -1574,10 +1564,8 @@
               <a:defRPr/>
             </a:pPr>
             <a:r>
-              <a:rPr/>
               <a:t>Move fast here — the headline is that there is nothing to fix. Zero duplicates, zero missing values, 1,470 unique employee numbers. Worth saying explicitly that this is a property of a curated teaching dataset and is not what a real HR extract looks like; the value of running these checks is that we now know the later segment denominators are trustworthy. The one substantive finding is the three constant columns, which get dropped downstream. Transition: with nothing to clean, preparation becomes about making the data legible.</a:t>
             </a:r>
-            <a:endParaRPr/>
           </a:p>
         </p:txBody>
       </p:sp>
@@ -1602,8 +1590,8 @@
 </file>
 
 <file path=ppt/notesSlides/notesSlide6.xml><?xml version="1.0" encoding="utf-8"?>
-<p:notes xmlns:a="http://schemas.openxmlformats.org/drawingml/2006/main" xmlns:r="http://schemas.openxmlformats.org/officeDocument/2006/relationships" xmlns:p="http://schemas.openxmlformats.org/presentationml/2006/main" xmlns:m="http://schemas.openxmlformats.org/officeDocument/2006/math" xmlns:w="http://schemas.openxmlformats.org/wordprocessingml/2006/main">
-  <p:cSld name="">
+<p:notes xmlns:a="http://schemas.openxmlformats.org/drawingml/2006/main" xmlns:r="http://schemas.openxmlformats.org/officeDocument/2006/relationships" xmlns:p="http://schemas.openxmlformats.org/presentationml/2006/main">
+  <p:cSld>
     <p:spTree>
       <p:nvGrpSpPr>
         <p:cNvPr id="1" name=""/>
@@ -1622,7 +1610,7 @@
         <p:nvSpPr>
           <p:cNvPr id="38665582" name="Slide Image Placeholder 1"/>
           <p:cNvSpPr>
-            <a:spLocks noChangeAspect="1" noGrp="1" noRot="1"/>
+            <a:spLocks noGrp="1" noRot="1" noChangeAspect="1"/>
           </p:cNvSpPr>
           <p:nvPr>
             <p:ph type="sldImg" idx="2"/>
@@ -1649,10 +1637,8 @@
               <a:defRPr/>
             </a:pPr>
             <a:r>
-              <a:rPr/>
               <a:t>Translate, do not read the code. The point of this notebook is that it produces a second, model-ready copy of the data rather than overwriting the original — so the descriptive notebooks keep human-readable labels like 'Sales Executive' while the model gets a 50-column numeric matrix. Two judgement calls worth mentioning if asked: PerformanceRating was collapsed to 0/1 because only ratings 3 and 4 actually occur in the data, and scaling was applied to the 14 continuous columns only — which is why the coefficient magnitudes in step 10 are not strictly comparable across feature types.</a:t>
             </a:r>
-            <a:endParaRPr/>
           </a:p>
         </p:txBody>
       </p:sp>
@@ -1677,8 +1663,8 @@
 </file>
 
 <file path=ppt/notesSlides/notesSlide7.xml><?xml version="1.0" encoding="utf-8"?>
-<p:notes xmlns:a="http://schemas.openxmlformats.org/drawingml/2006/main" xmlns:r="http://schemas.openxmlformats.org/officeDocument/2006/relationships" xmlns:p="http://schemas.openxmlformats.org/presentationml/2006/main" xmlns:m="http://schemas.openxmlformats.org/officeDocument/2006/math" xmlns:w="http://schemas.openxmlformats.org/wordprocessingml/2006/main">
-  <p:cSld name="">
+<p:notes xmlns:a="http://schemas.openxmlformats.org/drawingml/2006/main" xmlns:r="http://schemas.openxmlformats.org/officeDocument/2006/relationships" xmlns:p="http://schemas.openxmlformats.org/presentationml/2006/main">
+  <p:cSld>
     <p:spTree>
       <p:nvGrpSpPr>
         <p:cNvPr id="1" name=""/>
@@ -1697,7 +1683,7 @@
         <p:nvSpPr>
           <p:cNvPr id="2139792164" name="Slide Image Placeholder 1"/>
           <p:cNvSpPr>
-            <a:spLocks noChangeAspect="1" noGrp="1" noRot="1"/>
+            <a:spLocks noGrp="1" noRot="1" noChangeAspect="1"/>
           </p:cNvSpPr>
           <p:nvPr>
             <p:ph type="sldImg" idx="2"/>
@@ -1724,10 +1710,8 @@
               <a:defRPr/>
             </a:pPr>
             <a:r>
-              <a:rPr/>
               <a:t>The deliverable here is the grouped extract, and the chart is the first real result in the project. Numbers: Sales 20.63%, HR 19.05%, R&amp;D 13.84%, against a 16.1% baseline. Make the interpretation point carefully — R&amp;D is below baseline on rate but contributes 133 of the 237 total leavers because it holds 961 of 1,470 employees. Rate and volume answer different questions, which is exactly why notebook 05 adds excess attrition. Also flag the labelling caveat: the bins used here are re-derived in later notebooks with slightly different labels (10+ versus 11+ years) although the edges are identical.</a:t>
             </a:r>
-            <a:endParaRPr/>
           </a:p>
         </p:txBody>
       </p:sp>
@@ -1752,8 +1736,8 @@
 </file>
 
 <file path=ppt/notesSlides/notesSlide8.xml><?xml version="1.0" encoding="utf-8"?>
-<p:notes xmlns:a="http://schemas.openxmlformats.org/drawingml/2006/main" xmlns:r="http://schemas.openxmlformats.org/officeDocument/2006/relationships" xmlns:p="http://schemas.openxmlformats.org/presentationml/2006/main" xmlns:m="http://schemas.openxmlformats.org/officeDocument/2006/math" xmlns:w="http://schemas.openxmlformats.org/wordprocessingml/2006/main">
-  <p:cSld name="">
+<p:notes xmlns:a="http://schemas.openxmlformats.org/drawingml/2006/main" xmlns:r="http://schemas.openxmlformats.org/officeDocument/2006/relationships" xmlns:p="http://schemas.openxmlformats.org/presentationml/2006/main">
+  <p:cSld>
     <p:spTree>
       <p:nvGrpSpPr>
         <p:cNvPr id="1" name=""/>
@@ -1772,7 +1756,7 @@
         <p:nvSpPr>
           <p:cNvPr id="2012169878" name="Slide Image Placeholder 1"/>
           <p:cNvSpPr>
-            <a:spLocks noChangeAspect="1" noGrp="1" noRot="1"/>
+            <a:spLocks noGrp="1" noRot="1" noChangeAspect="1"/>
           </p:cNvSpPr>
           <p:nvPr>
             <p:ph type="sldImg" idx="2"/>
@@ -1799,10 +1783,8 @@
               <a:defRPr/>
             </a:pPr>
             <a:r>
-              <a:rPr/>
               <a:t>Lead with the single most quotable number in the project: Sales Representatives at 39.76%, nearly two and a half times the company rate. Then immediately temper it — that is 33 people out of 83, so the confidence interval is wide. The right-hand chart is the corrective: on excess departures, Laboratory Technicians tie Sales Representatives at about +20, and they are a 259-person group. If you only had budget for one intervention, excess is the chart that tells you where to spend it. Note the wording: over-represented, associated with — we have no evidence that the role causes the leaving. Transition: same question, by department and level.</a:t>
             </a:r>
-            <a:endParaRPr/>
           </a:p>
         </p:txBody>
       </p:sp>
@@ -1827,8 +1809,8 @@
 </file>
 
 <file path=ppt/notesSlides/notesSlide9.xml><?xml version="1.0" encoding="utf-8"?>
-<p:notes xmlns:a="http://schemas.openxmlformats.org/drawingml/2006/main" xmlns:r="http://schemas.openxmlformats.org/officeDocument/2006/relationships" xmlns:p="http://schemas.openxmlformats.org/presentationml/2006/main" xmlns:m="http://schemas.openxmlformats.org/officeDocument/2006/math" xmlns:w="http://schemas.openxmlformats.org/wordprocessingml/2006/main">
-  <p:cSld name="">
+<p:notes xmlns:a="http://schemas.openxmlformats.org/drawingml/2006/main" xmlns:r="http://schemas.openxmlformats.org/officeDocument/2006/relationships" xmlns:p="http://schemas.openxmlformats.org/presentationml/2006/main">
+  <p:cSld>
     <p:spTree>
       <p:nvGrpSpPr>
         <p:cNvPr id="1" name=""/>
@@ -1847,7 +1829,7 @@
         <p:nvSpPr>
           <p:cNvPr id="545599537" name="Slide Image Placeholder 1"/>
           <p:cNvSpPr>
-            <a:spLocks noChangeAspect="1" noGrp="1" noRot="1"/>
+            <a:spLocks noGrp="1" noRot="1" noChangeAspect="1"/>
           </p:cNvSpPr>
           <p:nvPr>
             <p:ph type="sldImg" idx="2"/>
@@ -1874,10 +1856,8 @@
               <a:defRPr/>
             </a:pPr>
             <a:r>
-              <a:rPr/>
               <a:t>The takeaway is that level beats department as an explanation. Entry level: 26.3% on 543 people, +55 excess departures — the single largest excess figure anywhere in the analysis. Compare that with Sales at +20 and HR at +2. Then make the confounding point, because someone will ask: Sales Representatives and Laboratory Technicians are largely level-1 roles, so we are looking at overlapping views of one group, not three independent risk factors. Disentangling them would need stratified rates, which this analysis does not do — that is an honest limitation, and it is on the What We Learned slide. Transition: so is this about being new?</a:t>
             </a:r>
-            <a:endParaRPr/>
           </a:p>
         </p:txBody>
       </p:sp>
@@ -1902,7 +1882,7 @@
 </file>
 
 <file path=ppt/slideLayouts/slideLayout1.xml><?xml version="1.0" encoding="utf-8"?>
-<p:sldLayout xmlns:a="http://schemas.openxmlformats.org/drawingml/2006/main" xmlns:r="http://schemas.openxmlformats.org/officeDocument/2006/relationships" xmlns:p="http://schemas.openxmlformats.org/presentationml/2006/main" xmlns:m="http://schemas.openxmlformats.org/officeDocument/2006/math" xmlns:w="http://schemas.openxmlformats.org/wordprocessingml/2006/main" matchingName="" preserve="1" showMasterPhAnim="0" showMasterSp="1" type="title" userDrawn="1">
+<p:sldLayout xmlns:a="http://schemas.openxmlformats.org/drawingml/2006/main" xmlns:r="http://schemas.openxmlformats.org/officeDocument/2006/relationships" xmlns:p="http://schemas.openxmlformats.org/presentationml/2006/main" showMasterPhAnim="0" type="title" preserve="1" userDrawn="1">
   <p:cSld name="Title Slide">
     <p:spTree>
       <p:nvGrpSpPr>
@@ -2091,7 +2071,7 @@
             </a:pPr>
             <a:fld id="{5BCAD085-E8A6-8845-BD4E-CB4CCA059FC4}" type="datetimeFigureOut">
               <a:rPr lang="en-US"/>
-              <a:t>9/12/2026</a:t>
+              <a:t>9/13/2026</a:t>
             </a:fld>
             <a:endParaRPr lang="en-US"/>
           </a:p>
@@ -2154,7 +2134,7 @@
 </file>
 
 <file path=ppt/slideLayouts/slideLayout10.xml><?xml version="1.0" encoding="utf-8"?>
-<p:sldLayout xmlns:a="http://schemas.openxmlformats.org/drawingml/2006/main" xmlns:r="http://schemas.openxmlformats.org/officeDocument/2006/relationships" xmlns:p="http://schemas.openxmlformats.org/presentationml/2006/main" xmlns:m="http://schemas.openxmlformats.org/officeDocument/2006/math" xmlns:w="http://schemas.openxmlformats.org/wordprocessingml/2006/main" matchingName="" preserve="1" showMasterPhAnim="0" showMasterSp="1" type="vertTx" userDrawn="1">
+<p:sldLayout xmlns:a="http://schemas.openxmlformats.org/drawingml/2006/main" xmlns:r="http://schemas.openxmlformats.org/officeDocument/2006/relationships" xmlns:p="http://schemas.openxmlformats.org/presentationml/2006/main" showMasterPhAnim="0" type="vertTx" preserve="1" userDrawn="1">
   <p:cSld name="Title and Vertical Text">
     <p:spTree>
       <p:nvGrpSpPr>
@@ -2282,7 +2262,7 @@
             </a:pPr>
             <a:fld id="{5BCAD085-E8A6-8845-BD4E-CB4CCA059FC4}" type="datetimeFigureOut">
               <a:rPr lang="en-US"/>
-              <a:t>9/12/2026</a:t>
+              <a:t>9/13/2026</a:t>
             </a:fld>
             <a:endParaRPr lang="en-US"/>
           </a:p>
@@ -2345,7 +2325,7 @@
 </file>
 
 <file path=ppt/slideLayouts/slideLayout11.xml><?xml version="1.0" encoding="utf-8"?>
-<p:sldLayout xmlns:a="http://schemas.openxmlformats.org/drawingml/2006/main" xmlns:r="http://schemas.openxmlformats.org/officeDocument/2006/relationships" xmlns:p="http://schemas.openxmlformats.org/presentationml/2006/main" xmlns:m="http://schemas.openxmlformats.org/officeDocument/2006/math" xmlns:w="http://schemas.openxmlformats.org/wordprocessingml/2006/main" matchingName="" preserve="1" showMasterPhAnim="0" showMasterSp="1" type="vertTitleAndTx" userDrawn="1">
+<p:sldLayout xmlns:a="http://schemas.openxmlformats.org/drawingml/2006/main" xmlns:r="http://schemas.openxmlformats.org/officeDocument/2006/relationships" xmlns:p="http://schemas.openxmlformats.org/presentationml/2006/main" showMasterPhAnim="0" type="vertTitleAndTx" preserve="1" userDrawn="1">
   <p:cSld name="Vertical Title and Text">
     <p:spTree>
       <p:nvGrpSpPr>
@@ -2483,7 +2463,7 @@
             </a:pPr>
             <a:fld id="{5BCAD085-E8A6-8845-BD4E-CB4CCA059FC4}" type="datetimeFigureOut">
               <a:rPr lang="en-US"/>
-              <a:t>9/12/2026</a:t>
+              <a:t>9/13/2026</a:t>
             </a:fld>
             <a:endParaRPr lang="en-US"/>
           </a:p>
@@ -2546,7 +2526,7 @@
 </file>
 
 <file path=ppt/slideLayouts/slideLayout2.xml><?xml version="1.0" encoding="utf-8"?>
-<p:sldLayout xmlns:a="http://schemas.openxmlformats.org/drawingml/2006/main" xmlns:r="http://schemas.openxmlformats.org/officeDocument/2006/relationships" xmlns:p="http://schemas.openxmlformats.org/presentationml/2006/main" xmlns:m="http://schemas.openxmlformats.org/officeDocument/2006/math" xmlns:w="http://schemas.openxmlformats.org/wordprocessingml/2006/main" matchingName="" preserve="1" showMasterPhAnim="0" showMasterSp="1" type="obj" userDrawn="1">
+<p:sldLayout xmlns:a="http://schemas.openxmlformats.org/drawingml/2006/main" xmlns:r="http://schemas.openxmlformats.org/officeDocument/2006/relationships" xmlns:p="http://schemas.openxmlformats.org/presentationml/2006/main" showMasterPhAnim="0" type="obj" preserve="1" userDrawn="1">
   <p:cSld name="Title and Content">
     <p:spTree>
       <p:nvGrpSpPr>
@@ -2674,7 +2654,7 @@
             </a:pPr>
             <a:fld id="{5BCAD085-E8A6-8845-BD4E-CB4CCA059FC4}" type="datetimeFigureOut">
               <a:rPr lang="en-US"/>
-              <a:t>9/12/2026</a:t>
+              <a:t>9/13/2026</a:t>
             </a:fld>
             <a:endParaRPr lang="en-US"/>
           </a:p>
@@ -2737,7 +2717,7 @@
 </file>
 
 <file path=ppt/slideLayouts/slideLayout3.xml><?xml version="1.0" encoding="utf-8"?>
-<p:sldLayout xmlns:a="http://schemas.openxmlformats.org/drawingml/2006/main" xmlns:r="http://schemas.openxmlformats.org/officeDocument/2006/relationships" xmlns:p="http://schemas.openxmlformats.org/presentationml/2006/main" xmlns:m="http://schemas.openxmlformats.org/officeDocument/2006/math" xmlns:w="http://schemas.openxmlformats.org/wordprocessingml/2006/main" matchingName="" preserve="1" showMasterPhAnim="0" showMasterSp="1" type="secHead" userDrawn="1">
+<p:sldLayout xmlns:a="http://schemas.openxmlformats.org/drawingml/2006/main" xmlns:r="http://schemas.openxmlformats.org/officeDocument/2006/relationships" xmlns:p="http://schemas.openxmlformats.org/presentationml/2006/main" showMasterPhAnim="0" type="secHead" preserve="1" userDrawn="1">
   <p:cSld name="Section Header">
     <p:spTree>
       <p:nvGrpSpPr>
@@ -2930,7 +2910,7 @@
             </a:pPr>
             <a:fld id="{5BCAD085-E8A6-8845-BD4E-CB4CCA059FC4}" type="datetimeFigureOut">
               <a:rPr lang="en-US"/>
-              <a:t>9/12/2026</a:t>
+              <a:t>9/13/2026</a:t>
             </a:fld>
             <a:endParaRPr lang="en-US"/>
           </a:p>
@@ -2993,7 +2973,7 @@
 </file>
 
 <file path=ppt/slideLayouts/slideLayout4.xml><?xml version="1.0" encoding="utf-8"?>
-<p:sldLayout xmlns:a="http://schemas.openxmlformats.org/drawingml/2006/main" xmlns:r="http://schemas.openxmlformats.org/officeDocument/2006/relationships" xmlns:p="http://schemas.openxmlformats.org/presentationml/2006/main" xmlns:m="http://schemas.openxmlformats.org/officeDocument/2006/math" xmlns:w="http://schemas.openxmlformats.org/wordprocessingml/2006/main" matchingName="" preserve="1" showMasterPhAnim="0" showMasterSp="1" type="twoObj" userDrawn="1">
+<p:sldLayout xmlns:a="http://schemas.openxmlformats.org/drawingml/2006/main" xmlns:r="http://schemas.openxmlformats.org/officeDocument/2006/relationships" xmlns:p="http://schemas.openxmlformats.org/presentationml/2006/main" showMasterPhAnim="0" type="twoObj" preserve="1" userDrawn="1">
   <p:cSld name="Two Content">
     <p:spTree>
       <p:nvGrpSpPr>
@@ -3253,7 +3233,7 @@
             </a:pPr>
             <a:fld id="{5BCAD085-E8A6-8845-BD4E-CB4CCA059FC4}" type="datetimeFigureOut">
               <a:rPr lang="en-US"/>
-              <a:t>9/12/2026</a:t>
+              <a:t>9/13/2026</a:t>
             </a:fld>
             <a:endParaRPr lang="en-US"/>
           </a:p>
@@ -3316,7 +3296,7 @@
 </file>
 
 <file path=ppt/slideLayouts/slideLayout5.xml><?xml version="1.0" encoding="utf-8"?>
-<p:sldLayout xmlns:a="http://schemas.openxmlformats.org/drawingml/2006/main" xmlns:r="http://schemas.openxmlformats.org/officeDocument/2006/relationships" xmlns:p="http://schemas.openxmlformats.org/presentationml/2006/main" xmlns:m="http://schemas.openxmlformats.org/officeDocument/2006/math" xmlns:w="http://schemas.openxmlformats.org/wordprocessingml/2006/main" matchingName="" preserve="1" showMasterPhAnim="0" showMasterSp="1" type="twoTxTwoObj" userDrawn="1">
+<p:sldLayout xmlns:a="http://schemas.openxmlformats.org/drawingml/2006/main" xmlns:r="http://schemas.openxmlformats.org/officeDocument/2006/relationships" xmlns:p="http://schemas.openxmlformats.org/presentationml/2006/main" showMasterPhAnim="0" type="twoTxTwoObj" preserve="1" userDrawn="1">
   <p:cSld name="Comparison">
     <p:spTree>
       <p:nvGrpSpPr>
@@ -3716,7 +3696,7 @@
             </a:pPr>
             <a:fld id="{5BCAD085-E8A6-8845-BD4E-CB4CCA059FC4}" type="datetimeFigureOut">
               <a:rPr lang="en-US"/>
-              <a:t>9/12/2026</a:t>
+              <a:t>9/13/2026</a:t>
             </a:fld>
             <a:endParaRPr lang="en-US"/>
           </a:p>
@@ -3779,7 +3759,7 @@
 </file>
 
 <file path=ppt/slideLayouts/slideLayout6.xml><?xml version="1.0" encoding="utf-8"?>
-<p:sldLayout xmlns:a="http://schemas.openxmlformats.org/drawingml/2006/main" xmlns:r="http://schemas.openxmlformats.org/officeDocument/2006/relationships" xmlns:p="http://schemas.openxmlformats.org/presentationml/2006/main" xmlns:m="http://schemas.openxmlformats.org/officeDocument/2006/math" xmlns:w="http://schemas.openxmlformats.org/wordprocessingml/2006/main" matchingName="" preserve="1" showMasterPhAnim="0" showMasterSp="1" type="titleOnly" userDrawn="1">
+<p:sldLayout xmlns:a="http://schemas.openxmlformats.org/drawingml/2006/main" xmlns:r="http://schemas.openxmlformats.org/officeDocument/2006/relationships" xmlns:p="http://schemas.openxmlformats.org/presentationml/2006/main" showMasterPhAnim="0" type="titleOnly" preserve="1" userDrawn="1">
   <p:cSld name="Title Only">
     <p:spTree>
       <p:nvGrpSpPr>
@@ -3841,7 +3821,7 @@
             </a:pPr>
             <a:fld id="{5BCAD085-E8A6-8845-BD4E-CB4CCA059FC4}" type="datetimeFigureOut">
               <a:rPr lang="en-US"/>
-              <a:t>9/12/2026</a:t>
+              <a:t>9/13/2026</a:t>
             </a:fld>
             <a:endParaRPr lang="en-US"/>
           </a:p>
@@ -3904,7 +3884,7 @@
 </file>
 
 <file path=ppt/slideLayouts/slideLayout7.xml><?xml version="1.0" encoding="utf-8"?>
-<p:sldLayout xmlns:a="http://schemas.openxmlformats.org/drawingml/2006/main" xmlns:r="http://schemas.openxmlformats.org/officeDocument/2006/relationships" xmlns:p="http://schemas.openxmlformats.org/presentationml/2006/main" xmlns:m="http://schemas.openxmlformats.org/officeDocument/2006/math" xmlns:w="http://schemas.openxmlformats.org/wordprocessingml/2006/main" matchingName="" preserve="1" showMasterPhAnim="0" showMasterSp="1" type="blank" userDrawn="1">
+<p:sldLayout xmlns:a="http://schemas.openxmlformats.org/drawingml/2006/main" xmlns:r="http://schemas.openxmlformats.org/officeDocument/2006/relationships" xmlns:p="http://schemas.openxmlformats.org/presentationml/2006/main" showMasterPhAnim="0" type="blank" preserve="1" userDrawn="1">
   <p:cSld name="Blank">
     <p:spTree>
       <p:nvGrpSpPr>
@@ -3940,7 +3920,7 @@
             </a:pPr>
             <a:fld id="{5BCAD085-E8A6-8845-BD4E-CB4CCA059FC4}" type="datetimeFigureOut">
               <a:rPr lang="en-US"/>
-              <a:t>9/12/2026</a:t>
+              <a:t>9/13/2026</a:t>
             </a:fld>
             <a:endParaRPr lang="en-US"/>
           </a:p>
@@ -4003,7 +3983,7 @@
 </file>
 
 <file path=ppt/slideLayouts/slideLayout8.xml><?xml version="1.0" encoding="utf-8"?>
-<p:sldLayout xmlns:a="http://schemas.openxmlformats.org/drawingml/2006/main" xmlns:r="http://schemas.openxmlformats.org/officeDocument/2006/relationships" xmlns:p="http://schemas.openxmlformats.org/presentationml/2006/main" xmlns:m="http://schemas.openxmlformats.org/officeDocument/2006/math" xmlns:w="http://schemas.openxmlformats.org/wordprocessingml/2006/main" matchingName="" preserve="1" showMasterPhAnim="0" showMasterSp="1" type="objTx" userDrawn="1">
+<p:sldLayout xmlns:a="http://schemas.openxmlformats.org/drawingml/2006/main" xmlns:r="http://schemas.openxmlformats.org/officeDocument/2006/relationships" xmlns:p="http://schemas.openxmlformats.org/presentationml/2006/main" showMasterPhAnim="0" type="objTx" preserve="1" userDrawn="1">
   <p:cSld name="Content with Caption">
     <p:spTree>
       <p:nvGrpSpPr>
@@ -4241,7 +4221,7 @@
             </a:pPr>
             <a:fld id="{5BCAD085-E8A6-8845-BD4E-CB4CCA059FC4}" type="datetimeFigureOut">
               <a:rPr lang="en-US"/>
-              <a:t>9/12/2026</a:t>
+              <a:t>9/13/2026</a:t>
             </a:fld>
             <a:endParaRPr lang="en-US"/>
           </a:p>
@@ -4304,7 +4284,7 @@
 </file>
 
 <file path=ppt/slideLayouts/slideLayout9.xml><?xml version="1.0" encoding="utf-8"?>
-<p:sldLayout xmlns:a="http://schemas.openxmlformats.org/drawingml/2006/main" xmlns:r="http://schemas.openxmlformats.org/officeDocument/2006/relationships" xmlns:p="http://schemas.openxmlformats.org/presentationml/2006/main" xmlns:m="http://schemas.openxmlformats.org/officeDocument/2006/math" xmlns:w="http://schemas.openxmlformats.org/wordprocessingml/2006/main" matchingName="" preserve="1" showMasterPhAnim="0" showMasterSp="1" type="picTx" userDrawn="1">
+<p:sldLayout xmlns:a="http://schemas.openxmlformats.org/drawingml/2006/main" xmlns:r="http://schemas.openxmlformats.org/officeDocument/2006/relationships" xmlns:p="http://schemas.openxmlformats.org/presentationml/2006/main" showMasterPhAnim="0" type="picTx" preserve="1" userDrawn="1">
   <p:cSld name="Picture with Caption">
     <p:spTree>
       <p:nvGrpSpPr>
@@ -4507,7 +4487,7 @@
             </a:pPr>
             <a:fld id="{5BCAD085-E8A6-8845-BD4E-CB4CCA059FC4}" type="datetimeFigureOut">
               <a:rPr lang="en-US"/>
-              <a:t>9/12/2026</a:t>
+              <a:t>9/13/2026</a:t>
             </a:fld>
             <a:endParaRPr lang="en-US"/>
           </a:p>
@@ -4570,8 +4550,8 @@
 </file>
 
 <file path=ppt/slideMasters/slideMaster1.xml><?xml version="1.0" encoding="utf-8"?>
-<p:sldMaster xmlns:a="http://schemas.openxmlformats.org/drawingml/2006/main" xmlns:r="http://schemas.openxmlformats.org/officeDocument/2006/relationships" xmlns:p="http://schemas.openxmlformats.org/presentationml/2006/main" xmlns:m="http://schemas.openxmlformats.org/officeDocument/2006/math" xmlns:w="http://schemas.openxmlformats.org/wordprocessingml/2006/main" preserve="0">
-  <p:cSld name="">
+<p:sldMaster xmlns:a="http://schemas.openxmlformats.org/drawingml/2006/main" xmlns:r="http://schemas.openxmlformats.org/officeDocument/2006/relationships" xmlns:p="http://schemas.openxmlformats.org/presentationml/2006/main">
+  <p:cSld>
     <p:bg>
       <p:bgRef idx="1001">
         <a:schemeClr val="bg1"/>
@@ -4741,7 +4721,7 @@
             </a:pPr>
             <a:fld id="{5BCAD085-E8A6-8845-BD4E-CB4CCA059FC4}" type="datetimeFigureOut">
               <a:rPr lang="en-US"/>
-              <a:t>9/12/2026</a:t>
+              <a:t>9/13/2026</a:t>
             </a:fld>
             <a:endParaRPr lang="en-US"/>
           </a:p>
@@ -5101,8 +5081,8 @@
 </file>
 
 <file path=ppt/slides/slide1.xml><?xml version="1.0" encoding="utf-8"?>
-<p:sld xmlns:a="http://schemas.openxmlformats.org/drawingml/2006/main" xmlns:r="http://schemas.openxmlformats.org/officeDocument/2006/relationships" xmlns:p="http://schemas.openxmlformats.org/presentationml/2006/main" xmlns:m="http://schemas.openxmlformats.org/officeDocument/2006/math" xmlns:w="http://schemas.openxmlformats.org/wordprocessingml/2006/main" xmlns:mc="http://schemas.openxmlformats.org/markup-compatibility/2006" showMasterPhAnim="0" showMasterSp="1" show="1">
-  <p:cSld name="">
+<p:sld xmlns:a="http://schemas.openxmlformats.org/drawingml/2006/main" xmlns:r="http://schemas.openxmlformats.org/officeDocument/2006/relationships" xmlns:p="http://schemas.openxmlformats.org/presentationml/2006/main" showMasterPhAnim="0">
+  <p:cSld>
     <p:spTree>
       <p:nvGrpSpPr>
         <p:cNvPr id="1" name=""/>
@@ -5416,7 +5396,7 @@
         <p:spPr bwMode="auto">
           <a:xfrm>
             <a:off x="960120" y="4526280"/>
-            <a:ext cx="10241280" cy="1005840"/>
+            <a:ext cx="10241280" cy="642099"/>
           </a:xfrm>
           <a:prstGeom prst="rect">
             <a:avLst/>
@@ -5429,34 +5409,54 @@
           </a:bodyPr>
           <a:lstStyle/>
           <a:p>
-            <a:pPr algn="l">
+            <a:pPr>
               <a:lnSpc>
                 <a:spcPct val="170000"/>
               </a:lnSpc>
-              <a:spcAft>
-                <a:spcPts val="0"/>
-              </a:spcAft>
-              <a:defRPr/>
-            </a:pPr>
-            <a:r>
-              <a:rPr sz="1400" b="1" i="0">
+              <a:defRPr/>
+            </a:pPr>
+            <a:r>
+              <a:rPr sz="1400" b="1" i="0" dirty="0" err="1">
                 <a:solidFill>
                   <a:srgbClr val="FFFFFF"/>
                 </a:solidFill>
                 <a:latin typeface="Segoe UI"/>
               </a:rPr>
-              <a:t>NPower JDA Cohort 2026  </a:t>
-            </a:r>
-            <a:r>
-              <a:rPr sz="1400" b="0" i="0">
+              <a:t>NPower</a:t>
+            </a:r>
+            <a:r>
+              <a:rPr sz="1400" b="1" i="0" dirty="0">
+                <a:solidFill>
+                  <a:srgbClr val="FFFFFF"/>
+                </a:solidFill>
+                <a:latin typeface="Segoe UI"/>
+              </a:rPr>
+              <a:t> JDA Cohort 2026</a:t>
+            </a:r>
+            <a:r>
+              <a:rPr lang="en-US" sz="1400" b="1" dirty="0">
+                <a:solidFill>
+                  <a:srgbClr val="FFFFFF"/>
+                </a:solidFill>
+                <a:latin typeface="Segoe UI"/>
+              </a:rPr>
+              <a:t>  </a:t>
+            </a:r>
+            <a:r>
+              <a:rPr lang="en-US" sz="1400" dirty="0">
                 <a:solidFill>
                   <a:srgbClr val="9EC5F4"/>
                 </a:solidFill>
                 <a:latin typeface="Segoe UI"/>
               </a:rPr>
-              <a:t>·  8-person team project</a:t>
-            </a:r>
-            <a:endParaRPr/>
+              <a:t>·  Group 7</a:t>
+            </a:r>
+            <a:endParaRPr lang="en-US" dirty="0">
+              <a:solidFill>
+                <a:srgbClr val="000000"/>
+              </a:solidFill>
+              <a:latin typeface="Calibri"/>
+            </a:endParaRPr>
           </a:p>
           <a:p>
             <a:pPr algn="l">
@@ -5469,15 +5469,42 @@
               <a:defRPr/>
             </a:pPr>
             <a:r>
-              <a:rPr sz="1200" b="0" i="0">
+              <a:rPr sz="1200" b="0" i="0" dirty="0">
                 <a:solidFill>
                   <a:srgbClr val="86B6EF"/>
                 </a:solidFill>
                 <a:latin typeface="Consolas"/>
               </a:rPr>
-              <a:t>github.com/NPower-JDA-Cohort-2026/ibm-analytics-attrition-eda</a:t>
-            </a:r>
-            <a:endParaRPr/>
+              <a:t>github.com/NPower-JDA-Cohort-2026/</a:t>
+            </a:r>
+            <a:r>
+              <a:rPr sz="1200" b="0" i="0" dirty="0" err="1">
+                <a:solidFill>
+                  <a:srgbClr val="86B6EF"/>
+                </a:solidFill>
+                <a:latin typeface="Consolas"/>
+              </a:rPr>
+              <a:t>ibm</a:t>
+            </a:r>
+            <a:r>
+              <a:rPr sz="1200" b="0" i="0" dirty="0">
+                <a:solidFill>
+                  <a:srgbClr val="86B6EF"/>
+                </a:solidFill>
+                <a:latin typeface="Consolas"/>
+              </a:rPr>
+              <a:t>-analytics-attrition-</a:t>
+            </a:r>
+            <a:r>
+              <a:rPr sz="1200" b="0" i="0" dirty="0" err="1">
+                <a:solidFill>
+                  <a:srgbClr val="86B6EF"/>
+                </a:solidFill>
+                <a:latin typeface="Consolas"/>
+              </a:rPr>
+              <a:t>eda</a:t>
+            </a:r>
+            <a:endParaRPr dirty="0" err="1"/>
           </a:p>
         </p:txBody>
       </p:sp>
@@ -5530,11 +5557,11 @@
   <p:clrMapOvr>
     <a:masterClrMapping/>
   </p:clrMapOvr>
-  <mc:AlternateContent xmlns:mc="http://schemas.openxmlformats.org/markup-compatibility/2006">
-    <mc:Choice xmlns:p159="http://schemas.microsoft.com/office/powerpoint/2015/09/main" xmlns:p14="http://schemas.microsoft.com/office/powerpoint/2010/main" Requires="p159">
-      <p:transition p14:dur="500" advClick="1"/>
+  <mc:AlternateContent xmlns:mc="http://schemas.openxmlformats.org/markup-compatibility/2006" xmlns:p159="http://schemas.microsoft.com/office/powerpoint/2015/09/main">
+    <mc:Choice Requires="p159">
+      <p:transition/>
     </mc:Choice>
-    <mc:Fallback>
+    <mc:Fallback xmlns:w="http://schemas.openxmlformats.org/wordprocessingml/2006/main" xmlns:m="http://schemas.openxmlformats.org/officeDocument/2006/math" xmlns="">
       <p:transition advClick="1"/>
     </mc:Fallback>
   </mc:AlternateContent>
@@ -5542,8 +5569,8 @@
 </file>
 
 <file path=ppt/slides/slide10.xml><?xml version="1.0" encoding="utf-8"?>
-<p:sld xmlns:a="http://schemas.openxmlformats.org/drawingml/2006/main" xmlns:r="http://schemas.openxmlformats.org/officeDocument/2006/relationships" xmlns:p="http://schemas.openxmlformats.org/presentationml/2006/main" xmlns:m="http://schemas.openxmlformats.org/officeDocument/2006/math" xmlns:w="http://schemas.openxmlformats.org/wordprocessingml/2006/main" xmlns:mc="http://schemas.openxmlformats.org/markup-compatibility/2006" showMasterPhAnim="0" showMasterSp="1" show="1">
-  <p:cSld name="">
+<p:sld xmlns:a="http://schemas.openxmlformats.org/drawingml/2006/main" xmlns:r="http://schemas.openxmlformats.org/officeDocument/2006/relationships" xmlns:p="http://schemas.openxmlformats.org/presentationml/2006/main" showMasterPhAnim="0">
+  <p:cSld>
     <p:spTree>
       <p:nvGrpSpPr>
         <p:cNvPr id="1" name=""/>
@@ -5781,28 +5808,6 @@
           </a:prstGeom>
         </p:spPr>
       </p:pic>
-      <p:pic>
-        <p:nvPicPr>
-          <p:cNvPr id="618663384" name="Picture 7" descr="05_early_signals.png"/>
-          <p:cNvPicPr>
-            <a:picLocks noChangeAspect="1"/>
-          </p:cNvPicPr>
-          <p:nvPr/>
-        </p:nvPicPr>
-        <p:blipFill rotWithShape="1">
-          <a:blip r:embed="rId5"/>
-          <a:stretch/>
-        </p:blipFill>
-        <p:spPr bwMode="auto">
-          <a:xfrm>
-            <a:off x="3436704" y="4425696"/>
-            <a:ext cx="5318560" cy="1481328"/>
-          </a:xfrm>
-          <a:prstGeom prst="rect">
-            <a:avLst/>
-          </a:prstGeom>
-        </p:spPr>
-      </p:pic>
       <p:sp>
         <p:nvSpPr>
           <p:cNvPr id="666688834" name="Rectangle 8"/>
@@ -5811,8 +5816,8 @@
         </p:nvSpPr>
         <p:spPr bwMode="auto">
           <a:xfrm>
-            <a:off x="566928" y="5138928"/>
-            <a:ext cx="5401040" cy="1005840"/>
+            <a:off x="603214" y="4839571"/>
+            <a:ext cx="5382897" cy="1187269"/>
           </a:xfrm>
           <a:prstGeom prst="rect">
             <a:avLst/>
@@ -5858,8 +5863,8 @@
         </p:nvSpPr>
         <p:spPr bwMode="auto">
           <a:xfrm>
-            <a:off x="566928" y="5138928"/>
-            <a:ext cx="41148" cy="1005840"/>
+            <a:off x="557857" y="4839571"/>
+            <a:ext cx="41148" cy="1187268"/>
           </a:xfrm>
           <a:prstGeom prst="rect">
             <a:avLst/>
@@ -5905,7 +5910,7 @@
         </p:nvSpPr>
         <p:spPr bwMode="auto">
           <a:xfrm>
-            <a:off x="786384" y="5276088"/>
+            <a:off x="786384" y="4922302"/>
             <a:ext cx="4998704" cy="219456"/>
           </a:xfrm>
           <a:prstGeom prst="rect">
@@ -5949,7 +5954,7 @@
         </p:nvSpPr>
         <p:spPr bwMode="auto">
           <a:xfrm>
-            <a:off x="786384" y="5522976"/>
+            <a:off x="786384" y="5241762"/>
             <a:ext cx="4998704" cy="512064"/>
           </a:xfrm>
           <a:prstGeom prst="rect">
@@ -5993,8 +5998,8 @@
         </p:nvSpPr>
         <p:spPr bwMode="auto">
           <a:xfrm>
-            <a:off x="6224000" y="5138928"/>
-            <a:ext cx="5401040" cy="1005840"/>
+            <a:off x="6224000" y="4839571"/>
+            <a:ext cx="5391969" cy="1187268"/>
           </a:xfrm>
           <a:prstGeom prst="rect">
             <a:avLst/>
@@ -6040,8 +6045,8 @@
         </p:nvSpPr>
         <p:spPr bwMode="auto">
           <a:xfrm>
-            <a:off x="6224000" y="5138928"/>
-            <a:ext cx="41148" cy="1005840"/>
+            <a:off x="6169572" y="4839571"/>
+            <a:ext cx="50220" cy="1187267"/>
           </a:xfrm>
           <a:prstGeom prst="rect">
             <a:avLst/>
@@ -6087,7 +6092,7 @@
         </p:nvSpPr>
         <p:spPr bwMode="auto">
           <a:xfrm>
-            <a:off x="6443456" y="5276088"/>
+            <a:off x="6416242" y="4922302"/>
             <a:ext cx="4998704" cy="219456"/>
           </a:xfrm>
           <a:prstGeom prst="rect">
@@ -6131,7 +6136,7 @@
         </p:nvSpPr>
         <p:spPr bwMode="auto">
           <a:xfrm>
-            <a:off x="6443456" y="5522976"/>
+            <a:off x="6425313" y="5178262"/>
             <a:ext cx="4998704" cy="512064"/>
           </a:xfrm>
           <a:prstGeom prst="rect">
@@ -6307,11 +6312,11 @@
   <p:clrMapOvr>
     <a:masterClrMapping/>
   </p:clrMapOvr>
-  <mc:AlternateContent xmlns:mc="http://schemas.openxmlformats.org/markup-compatibility/2006">
-    <mc:Choice xmlns:p159="http://schemas.microsoft.com/office/powerpoint/2015/09/main" xmlns:p14="http://schemas.microsoft.com/office/powerpoint/2010/main" Requires="p159">
-      <p:transition p14:dur="500" advClick="1"/>
+  <mc:AlternateContent xmlns:mc="http://schemas.openxmlformats.org/markup-compatibility/2006" xmlns:p159="http://schemas.microsoft.com/office/powerpoint/2015/09/main">
+    <mc:Choice Requires="p159">
+      <p:transition/>
     </mc:Choice>
-    <mc:Fallback>
+    <mc:Fallback xmlns:w="http://schemas.openxmlformats.org/wordprocessingml/2006/main" xmlns:m="http://schemas.openxmlformats.org/officeDocument/2006/math" xmlns="">
       <p:transition advClick="1"/>
     </mc:Fallback>
   </mc:AlternateContent>
@@ -6319,8 +6324,8 @@
 </file>
 
 <file path=ppt/slides/slide11.xml><?xml version="1.0" encoding="utf-8"?>
-<p:sld xmlns:a="http://schemas.openxmlformats.org/drawingml/2006/main" xmlns:r="http://schemas.openxmlformats.org/officeDocument/2006/relationships" xmlns:p="http://schemas.openxmlformats.org/presentationml/2006/main" xmlns:m="http://schemas.openxmlformats.org/officeDocument/2006/math" xmlns:w="http://schemas.openxmlformats.org/wordprocessingml/2006/main" xmlns:mc="http://schemas.openxmlformats.org/markup-compatibility/2006" showMasterPhAnim="0" showMasterSp="1" show="1">
-  <p:cSld name="">
+<p:sld xmlns:a="http://schemas.openxmlformats.org/drawingml/2006/main" xmlns:r="http://schemas.openxmlformats.org/officeDocument/2006/relationships" xmlns:p="http://schemas.openxmlformats.org/presentationml/2006/main" showMasterPhAnim="0">
+  <p:cSld>
     <p:spTree>
       <p:nvGrpSpPr>
         <p:cNvPr id="1" name=""/>
@@ -6699,31 +6704,7 @@
             </a:pPr>
             <a:r>
               <a:rPr lang="en-CA" sz="1200"/>
-              <a:t>Continuous variables (</a:t>
-            </a:r>
-            <a:r>
-              <a:rPr lang="en-CA" sz="1200"/>
-              <a:t>MonthlyIncome</a:t>
-            </a:r>
-            <a:r>
-              <a:rPr lang="en-CA" sz="1200"/>
-              <a:t>, </a:t>
-            </a:r>
-            <a:r>
-              <a:rPr lang="en-CA" sz="1200"/>
-              <a:t>TotalWorkingYears</a:t>
-            </a:r>
-            <a:r>
-              <a:rPr lang="en-CA" sz="1200"/>
-              <a:t>, </a:t>
-            </a:r>
-            <a:r>
-              <a:rPr lang="en-CA" sz="1200"/>
-              <a:t>YearsAtCompany</a:t>
-            </a:r>
-            <a:r>
-              <a:rPr lang="en-CA" sz="1200"/>
-              <a:t>) displayed strong left-skewed distributions with long lower tails.</a:t>
+              <a:t>Continuous variables (MonthlyIncome, TotalWorkingYears, YearsAtCompany) displayed strong left-skewed distributions with long lower tails.</a:t>
             </a:r>
             <a:endParaRPr/>
           </a:p>
@@ -6738,31 +6719,7 @@
             </a:pPr>
             <a:r>
               <a:rPr lang="en-CA" sz="1200"/>
-              <a:t>Ordinal survey variables (</a:t>
-            </a:r>
-            <a:r>
-              <a:rPr lang="en-CA" sz="1200"/>
-              <a:t>JobSatisfaction</a:t>
-            </a:r>
-            <a:r>
-              <a:rPr lang="en-CA" sz="1200"/>
-              <a:t>, </a:t>
-            </a:r>
-            <a:r>
-              <a:rPr lang="en-CA" sz="1200"/>
-              <a:t>EnvironmentSatisfaction</a:t>
-            </a:r>
-            <a:r>
-              <a:rPr lang="en-CA" sz="1200"/>
-              <a:t>, </a:t>
-            </a:r>
-            <a:r>
-              <a:rPr lang="en-CA" sz="1200"/>
-              <a:t>WorkLifeBalance</a:t>
-            </a:r>
-            <a:r>
-              <a:rPr lang="en-CA" sz="1200"/>
-              <a:t>) clustered around mid-higher values.</a:t>
+              <a:t>Ordinal survey variables (JobSatisfaction, EnvironmentSatisfaction, WorkLifeBalance) clustered around mid-higher values.</a:t>
             </a:r>
             <a:endParaRPr/>
           </a:p>
@@ -7157,11 +7114,11 @@
   <p:clrMapOvr>
     <a:masterClrMapping/>
   </p:clrMapOvr>
-  <mc:AlternateContent xmlns:mc="http://schemas.openxmlformats.org/markup-compatibility/2006">
-    <mc:Choice xmlns:p159="http://schemas.microsoft.com/office/powerpoint/2015/09/main" xmlns:p14="http://schemas.microsoft.com/office/powerpoint/2010/main" Requires="p159">
-      <p:transition p14:dur="500" advClick="1"/>
+  <mc:AlternateContent xmlns:mc="http://schemas.openxmlformats.org/markup-compatibility/2006" xmlns:p159="http://schemas.microsoft.com/office/powerpoint/2015/09/main">
+    <mc:Choice Requires="p159">
+      <p:transition/>
     </mc:Choice>
-    <mc:Fallback>
+    <mc:Fallback xmlns:w="http://schemas.openxmlformats.org/wordprocessingml/2006/main" xmlns:m="http://schemas.openxmlformats.org/officeDocument/2006/math" xmlns="">
       <p:transition advClick="1"/>
     </mc:Fallback>
   </mc:AlternateContent>
@@ -7169,8 +7126,8 @@
 </file>
 
 <file path=ppt/slides/slide12.xml><?xml version="1.0" encoding="utf-8"?>
-<p:sld xmlns:a="http://schemas.openxmlformats.org/drawingml/2006/main" xmlns:r="http://schemas.openxmlformats.org/officeDocument/2006/relationships" xmlns:p="http://schemas.openxmlformats.org/presentationml/2006/main" xmlns:m="http://schemas.openxmlformats.org/officeDocument/2006/math" xmlns:w="http://schemas.openxmlformats.org/wordprocessingml/2006/main" xmlns:mc="http://schemas.openxmlformats.org/markup-compatibility/2006" showMasterPhAnim="0" showMasterSp="1" show="1">
-  <p:cSld name="">
+<p:sld xmlns:a="http://schemas.openxmlformats.org/drawingml/2006/main" xmlns:r="http://schemas.openxmlformats.org/officeDocument/2006/relationships" xmlns:p="http://schemas.openxmlformats.org/presentationml/2006/main" showMasterPhAnim="0">
+  <p:cSld>
     <p:spTree>
       <p:nvGrpSpPr>
         <p:cNvPr id="1" name=""/>
@@ -8256,11 +8213,11 @@
   <p:clrMapOvr>
     <a:masterClrMapping/>
   </p:clrMapOvr>
-  <mc:AlternateContent xmlns:mc="http://schemas.openxmlformats.org/markup-compatibility/2006">
-    <mc:Choice xmlns:p159="http://schemas.microsoft.com/office/powerpoint/2015/09/main" xmlns:p14="http://schemas.microsoft.com/office/powerpoint/2010/main" Requires="p159">
-      <p:transition p14:dur="500" advClick="1"/>
+  <mc:AlternateContent xmlns:mc="http://schemas.openxmlformats.org/markup-compatibility/2006" xmlns:p159="http://schemas.microsoft.com/office/powerpoint/2015/09/main">
+    <mc:Choice Requires="p159">
+      <p:transition/>
     </mc:Choice>
-    <mc:Fallback>
+    <mc:Fallback xmlns:w="http://schemas.openxmlformats.org/wordprocessingml/2006/main" xmlns:m="http://schemas.openxmlformats.org/officeDocument/2006/math" xmlns="">
       <p:transition advClick="1"/>
     </mc:Fallback>
   </mc:AlternateContent>
@@ -8268,8 +8225,8 @@
 </file>
 
 <file path=ppt/slides/slide13.xml><?xml version="1.0" encoding="utf-8"?>
-<p:sld xmlns:a="http://schemas.openxmlformats.org/drawingml/2006/main" xmlns:r="http://schemas.openxmlformats.org/officeDocument/2006/relationships" xmlns:p="http://schemas.openxmlformats.org/presentationml/2006/main" xmlns:m="http://schemas.openxmlformats.org/officeDocument/2006/math" xmlns:w="http://schemas.openxmlformats.org/wordprocessingml/2006/main" xmlns:mc="http://schemas.openxmlformats.org/markup-compatibility/2006" showMasterPhAnim="0" showMasterSp="1" show="1">
-  <p:cSld name="">
+<p:sld xmlns:a="http://schemas.openxmlformats.org/drawingml/2006/main" xmlns:r="http://schemas.openxmlformats.org/officeDocument/2006/relationships" xmlns:p="http://schemas.openxmlformats.org/presentationml/2006/main" showMasterPhAnim="0">
+  <p:cSld>
     <p:spTree>
       <p:nvGrpSpPr>
         <p:cNvPr id="1" name=""/>
@@ -8663,15 +8620,7 @@
             </a:pPr>
             <a:r>
               <a:rPr lang="en-CA" sz="1400"/>
-              <a:t>The only notable positive relationship was </a:t>
-            </a:r>
-            <a:r>
-              <a:rPr lang="en-CA" sz="1400"/>
-              <a:t>DistanceFromHome</a:t>
-            </a:r>
-            <a:r>
-              <a:rPr lang="en-CA" sz="1400"/>
-              <a:t> (+0.078), suggesting attrition tends to increase as commute distance grows.</a:t>
+              <a:t>The only notable positive relationship was DistanceFromHome (+0.078), suggesting attrition tends to increase as commute distance grows.</a:t>
             </a:r>
             <a:endParaRPr/>
           </a:p>
@@ -9067,11 +9016,11 @@
   <p:clrMapOvr>
     <a:masterClrMapping/>
   </p:clrMapOvr>
-  <mc:AlternateContent xmlns:mc="http://schemas.openxmlformats.org/markup-compatibility/2006">
-    <mc:Choice xmlns:p159="http://schemas.microsoft.com/office/powerpoint/2015/09/main" xmlns:p14="http://schemas.microsoft.com/office/powerpoint/2010/main" Requires="p159">
-      <p:transition p14:dur="500" advClick="1"/>
+  <mc:AlternateContent xmlns:mc="http://schemas.openxmlformats.org/markup-compatibility/2006" xmlns:p159="http://schemas.microsoft.com/office/powerpoint/2015/09/main">
+    <mc:Choice Requires="p159">
+      <p:transition/>
     </mc:Choice>
-    <mc:Fallback>
+    <mc:Fallback xmlns:w="http://schemas.openxmlformats.org/wordprocessingml/2006/main" xmlns:m="http://schemas.openxmlformats.org/officeDocument/2006/math" xmlns="">
       <p:transition advClick="1"/>
     </mc:Fallback>
   </mc:AlternateContent>
@@ -9079,8 +9028,8 @@
 </file>
 
 <file path=ppt/slides/slide14.xml><?xml version="1.0" encoding="utf-8"?>
-<p:sld xmlns:a="http://schemas.openxmlformats.org/drawingml/2006/main" xmlns:r="http://schemas.openxmlformats.org/officeDocument/2006/relationships" xmlns:p="http://schemas.openxmlformats.org/presentationml/2006/main" xmlns:m="http://schemas.openxmlformats.org/officeDocument/2006/math" xmlns:w="http://schemas.openxmlformats.org/wordprocessingml/2006/main" xmlns:mc="http://schemas.openxmlformats.org/markup-compatibility/2006" showMasterPhAnim="0" showMasterSp="1" show="1">
-  <p:cSld name="">
+<p:sld xmlns:a="http://schemas.openxmlformats.org/drawingml/2006/main" xmlns:r="http://schemas.openxmlformats.org/officeDocument/2006/relationships" xmlns:p="http://schemas.openxmlformats.org/presentationml/2006/main" showMasterPhAnim="0">
+  <p:cSld>
     <p:spTree>
       <p:nvGrpSpPr>
         <p:cNvPr id="1" name=""/>
@@ -10023,11 +9972,11 @@
   <p:clrMapOvr>
     <a:masterClrMapping/>
   </p:clrMapOvr>
-  <mc:AlternateContent xmlns:mc="http://schemas.openxmlformats.org/markup-compatibility/2006">
-    <mc:Choice xmlns:p159="http://schemas.microsoft.com/office/powerpoint/2015/09/main" xmlns:p14="http://schemas.microsoft.com/office/powerpoint/2010/main" Requires="p159">
-      <p:transition p14:dur="500" advClick="1"/>
+  <mc:AlternateContent xmlns:mc="http://schemas.openxmlformats.org/markup-compatibility/2006" xmlns:p159="http://schemas.microsoft.com/office/powerpoint/2015/09/main">
+    <mc:Choice Requires="p159">
+      <p:transition/>
     </mc:Choice>
-    <mc:Fallback>
+    <mc:Fallback xmlns:w="http://schemas.openxmlformats.org/wordprocessingml/2006/main" xmlns:m="http://schemas.openxmlformats.org/officeDocument/2006/math" xmlns="">
       <p:transition advClick="1"/>
     </mc:Fallback>
   </mc:AlternateContent>
@@ -10035,8 +9984,8 @@
 </file>
 
 <file path=ppt/slides/slide15.xml><?xml version="1.0" encoding="utf-8"?>
-<p:sld xmlns:a="http://schemas.openxmlformats.org/drawingml/2006/main" xmlns:r="http://schemas.openxmlformats.org/officeDocument/2006/relationships" xmlns:p="http://schemas.openxmlformats.org/presentationml/2006/main" xmlns:m="http://schemas.openxmlformats.org/officeDocument/2006/math" xmlns:w="http://schemas.openxmlformats.org/wordprocessingml/2006/main" xmlns:mc="http://schemas.openxmlformats.org/markup-compatibility/2006" showMasterPhAnim="0" showMasterSp="1" show="1">
-  <p:cSld name="">
+<p:sld xmlns:a="http://schemas.openxmlformats.org/drawingml/2006/main" xmlns:r="http://schemas.openxmlformats.org/officeDocument/2006/relationships" xmlns:p="http://schemas.openxmlformats.org/presentationml/2006/main" showMasterPhAnim="0">
+  <p:cSld>
     <p:spTree>
       <p:nvGrpSpPr>
         <p:cNvPr id="1" name=""/>
@@ -11230,11 +11179,11 @@
   <p:clrMapOvr>
     <a:masterClrMapping/>
   </p:clrMapOvr>
-  <mc:AlternateContent xmlns:mc="http://schemas.openxmlformats.org/markup-compatibility/2006">
-    <mc:Choice xmlns:p159="http://schemas.microsoft.com/office/powerpoint/2015/09/main" xmlns:p14="http://schemas.microsoft.com/office/powerpoint/2010/main" Requires="p159">
-      <p:transition p14:dur="500" advClick="1"/>
+  <mc:AlternateContent xmlns:mc="http://schemas.openxmlformats.org/markup-compatibility/2006" xmlns:p159="http://schemas.microsoft.com/office/powerpoint/2015/09/main">
+    <mc:Choice Requires="p159">
+      <p:transition/>
     </mc:Choice>
-    <mc:Fallback>
+    <mc:Fallback xmlns:w="http://schemas.openxmlformats.org/wordprocessingml/2006/main" xmlns:m="http://schemas.openxmlformats.org/officeDocument/2006/math" xmlns="">
       <p:transition advClick="1"/>
     </mc:Fallback>
   </mc:AlternateContent>
@@ -11242,8 +11191,8 @@
 </file>
 
 <file path=ppt/slides/slide16.xml><?xml version="1.0" encoding="utf-8"?>
-<p:sld xmlns:a="http://schemas.openxmlformats.org/drawingml/2006/main" xmlns:r="http://schemas.openxmlformats.org/officeDocument/2006/relationships" xmlns:p="http://schemas.openxmlformats.org/presentationml/2006/main" xmlns:m="http://schemas.openxmlformats.org/officeDocument/2006/math" xmlns:w="http://schemas.openxmlformats.org/wordprocessingml/2006/main" xmlns:mc="http://schemas.openxmlformats.org/markup-compatibility/2006" showMasterPhAnim="0" showMasterSp="1" show="1">
-  <p:cSld name="">
+<p:sld xmlns:a="http://schemas.openxmlformats.org/drawingml/2006/main" xmlns:r="http://schemas.openxmlformats.org/officeDocument/2006/relationships" xmlns:p="http://schemas.openxmlformats.org/presentationml/2006/main" showMasterPhAnim="0">
+  <p:cSld>
     <p:spTree>
       <p:nvGrpSpPr>
         <p:cNvPr id="1" name=""/>
@@ -13329,11 +13278,11 @@
   <p:clrMapOvr>
     <a:masterClrMapping/>
   </p:clrMapOvr>
-  <mc:AlternateContent xmlns:mc="http://schemas.openxmlformats.org/markup-compatibility/2006">
-    <mc:Choice xmlns:p159="http://schemas.microsoft.com/office/powerpoint/2015/09/main" xmlns:p14="http://schemas.microsoft.com/office/powerpoint/2010/main" Requires="p159">
-      <p:transition p14:dur="500" advClick="1"/>
+  <mc:AlternateContent xmlns:mc="http://schemas.openxmlformats.org/markup-compatibility/2006" xmlns:p159="http://schemas.microsoft.com/office/powerpoint/2015/09/main">
+    <mc:Choice Requires="p159">
+      <p:transition/>
     </mc:Choice>
-    <mc:Fallback>
+    <mc:Fallback xmlns:w="http://schemas.openxmlformats.org/wordprocessingml/2006/main" xmlns:m="http://schemas.openxmlformats.org/officeDocument/2006/math" xmlns="">
       <p:transition advClick="1"/>
     </mc:Fallback>
   </mc:AlternateContent>
@@ -13341,8 +13290,8 @@
 </file>
 
 <file path=ppt/slides/slide17.xml><?xml version="1.0" encoding="utf-8"?>
-<p:sld xmlns:a="http://schemas.openxmlformats.org/drawingml/2006/main" xmlns:r="http://schemas.openxmlformats.org/officeDocument/2006/relationships" xmlns:p="http://schemas.openxmlformats.org/presentationml/2006/main" xmlns:m="http://schemas.openxmlformats.org/officeDocument/2006/math" xmlns:w="http://schemas.openxmlformats.org/wordprocessingml/2006/main" xmlns:mc="http://schemas.openxmlformats.org/markup-compatibility/2006" showMasterPhAnim="0" showMasterSp="1" show="1">
-  <p:cSld name="">
+<p:sld xmlns:a="http://schemas.openxmlformats.org/drawingml/2006/main" xmlns:r="http://schemas.openxmlformats.org/officeDocument/2006/relationships" xmlns:p="http://schemas.openxmlformats.org/presentationml/2006/main" showMasterPhAnim="0">
+  <p:cSld>
     <p:spTree>
       <p:nvGrpSpPr>
         <p:cNvPr id="1" name=""/>
@@ -14925,11 +14874,11 @@
   <p:clrMapOvr>
     <a:masterClrMapping/>
   </p:clrMapOvr>
-  <mc:AlternateContent xmlns:mc="http://schemas.openxmlformats.org/markup-compatibility/2006">
-    <mc:Choice xmlns:p159="http://schemas.microsoft.com/office/powerpoint/2015/09/main" xmlns:p14="http://schemas.microsoft.com/office/powerpoint/2010/main" Requires="p159">
-      <p:transition p14:dur="500" advClick="1"/>
+  <mc:AlternateContent xmlns:mc="http://schemas.openxmlformats.org/markup-compatibility/2006" xmlns:p159="http://schemas.microsoft.com/office/powerpoint/2015/09/main">
+    <mc:Choice Requires="p159">
+      <p:transition/>
     </mc:Choice>
-    <mc:Fallback>
+    <mc:Fallback xmlns:w="http://schemas.openxmlformats.org/wordprocessingml/2006/main" xmlns:m="http://schemas.openxmlformats.org/officeDocument/2006/math" xmlns="">
       <p:transition advClick="1"/>
     </mc:Fallback>
   </mc:AlternateContent>
@@ -14937,8 +14886,8 @@
 </file>
 
 <file path=ppt/slides/slide18.xml><?xml version="1.0" encoding="utf-8"?>
-<p:sld xmlns:a="http://schemas.openxmlformats.org/drawingml/2006/main" xmlns:r="http://schemas.openxmlformats.org/officeDocument/2006/relationships" xmlns:p="http://schemas.openxmlformats.org/presentationml/2006/main" xmlns:m="http://schemas.openxmlformats.org/officeDocument/2006/math" xmlns:w="http://schemas.openxmlformats.org/wordprocessingml/2006/main" xmlns:mc="http://schemas.openxmlformats.org/markup-compatibility/2006" showMasterPhAnim="0" showMasterSp="1" show="1">
-  <p:cSld name="">
+<p:sld xmlns:a="http://schemas.openxmlformats.org/drawingml/2006/main" xmlns:r="http://schemas.openxmlformats.org/officeDocument/2006/relationships" xmlns:p="http://schemas.openxmlformats.org/presentationml/2006/main" showMasterPhAnim="0">
+  <p:cSld>
     <p:spTree>
       <p:nvGrpSpPr>
         <p:cNvPr id="1" name=""/>
@@ -15986,11 +15935,11 @@
   <p:clrMapOvr>
     <a:masterClrMapping/>
   </p:clrMapOvr>
-  <mc:AlternateContent xmlns:mc="http://schemas.openxmlformats.org/markup-compatibility/2006">
-    <mc:Choice xmlns:p159="http://schemas.microsoft.com/office/powerpoint/2015/09/main" xmlns:p14="http://schemas.microsoft.com/office/powerpoint/2010/main" Requires="p159">
-      <p:transition p14:dur="500" advClick="1"/>
+  <mc:AlternateContent xmlns:mc="http://schemas.openxmlformats.org/markup-compatibility/2006" xmlns:p159="http://schemas.microsoft.com/office/powerpoint/2015/09/main">
+    <mc:Choice Requires="p159">
+      <p:transition/>
     </mc:Choice>
-    <mc:Fallback>
+    <mc:Fallback xmlns:w="http://schemas.openxmlformats.org/wordprocessingml/2006/main" xmlns:m="http://schemas.openxmlformats.org/officeDocument/2006/math" xmlns="">
       <p:transition advClick="1"/>
     </mc:Fallback>
   </mc:AlternateContent>
@@ -15998,8 +15947,8 @@
 </file>
 
 <file path=ppt/slides/slide19.xml><?xml version="1.0" encoding="utf-8"?>
-<p:sld xmlns:a="http://schemas.openxmlformats.org/drawingml/2006/main" xmlns:r="http://schemas.openxmlformats.org/officeDocument/2006/relationships" xmlns:p="http://schemas.openxmlformats.org/presentationml/2006/main" xmlns:m="http://schemas.openxmlformats.org/officeDocument/2006/math" xmlns:w="http://schemas.openxmlformats.org/wordprocessingml/2006/main" xmlns:mc="http://schemas.openxmlformats.org/markup-compatibility/2006" showMasterPhAnim="0" showMasterSp="1" show="1">
-  <p:cSld name="">
+<p:sld xmlns:a="http://schemas.openxmlformats.org/drawingml/2006/main" xmlns:r="http://schemas.openxmlformats.org/officeDocument/2006/relationships" xmlns:p="http://schemas.openxmlformats.org/presentationml/2006/main" showMasterPhAnim="0">
+  <p:cSld>
     <p:spTree>
       <p:nvGrpSpPr>
         <p:cNvPr id="1" name=""/>
@@ -18263,11 +18212,11 @@
   <p:clrMapOvr>
     <a:masterClrMapping/>
   </p:clrMapOvr>
-  <mc:AlternateContent xmlns:mc="http://schemas.openxmlformats.org/markup-compatibility/2006">
-    <mc:Choice xmlns:p159="http://schemas.microsoft.com/office/powerpoint/2015/09/main" xmlns:p14="http://schemas.microsoft.com/office/powerpoint/2010/main" Requires="p159">
-      <p:transition p14:dur="500" advClick="1"/>
+  <mc:AlternateContent xmlns:mc="http://schemas.openxmlformats.org/markup-compatibility/2006" xmlns:p159="http://schemas.microsoft.com/office/powerpoint/2015/09/main">
+    <mc:Choice Requires="p159">
+      <p:transition/>
     </mc:Choice>
-    <mc:Fallback>
+    <mc:Fallback xmlns:w="http://schemas.openxmlformats.org/wordprocessingml/2006/main" xmlns:m="http://schemas.openxmlformats.org/officeDocument/2006/math" xmlns="">
       <p:transition advClick="1"/>
     </mc:Fallback>
   </mc:AlternateContent>
@@ -18275,8 +18224,8 @@
 </file>
 
 <file path=ppt/slides/slide2.xml><?xml version="1.0" encoding="utf-8"?>
-<p:sld xmlns:a="http://schemas.openxmlformats.org/drawingml/2006/main" xmlns:r="http://schemas.openxmlformats.org/officeDocument/2006/relationships" xmlns:p="http://schemas.openxmlformats.org/presentationml/2006/main" xmlns:m="http://schemas.openxmlformats.org/officeDocument/2006/math" xmlns:w="http://schemas.openxmlformats.org/wordprocessingml/2006/main" xmlns:mc="http://schemas.openxmlformats.org/markup-compatibility/2006" showMasterPhAnim="0" showMasterSp="1" show="1">
-  <p:cSld name="">
+<p:sld xmlns:a="http://schemas.openxmlformats.org/drawingml/2006/main" xmlns:r="http://schemas.openxmlformats.org/officeDocument/2006/relationships" xmlns:p="http://schemas.openxmlformats.org/presentationml/2006/main" showMasterPhAnim="0">
+  <p:cSld>
     <p:spTree>
       <p:nvGrpSpPr>
         <p:cNvPr id="1" name=""/>
@@ -19299,11 +19248,11 @@
   <p:clrMapOvr>
     <a:masterClrMapping/>
   </p:clrMapOvr>
-  <mc:AlternateContent xmlns:mc="http://schemas.openxmlformats.org/markup-compatibility/2006">
-    <mc:Choice xmlns:p159="http://schemas.microsoft.com/office/powerpoint/2015/09/main" xmlns:p14="http://schemas.microsoft.com/office/powerpoint/2010/main" Requires="p159">
-      <p:transition p14:dur="500" advClick="1"/>
+  <mc:AlternateContent xmlns:mc="http://schemas.openxmlformats.org/markup-compatibility/2006" xmlns:p159="http://schemas.microsoft.com/office/powerpoint/2015/09/main">
+    <mc:Choice Requires="p159">
+      <p:transition/>
     </mc:Choice>
-    <mc:Fallback>
+    <mc:Fallback xmlns:w="http://schemas.openxmlformats.org/wordprocessingml/2006/main" xmlns:m="http://schemas.openxmlformats.org/officeDocument/2006/math" xmlns="">
       <p:transition advClick="1"/>
     </mc:Fallback>
   </mc:AlternateContent>
@@ -19311,8 +19260,8 @@
 </file>
 
 <file path=ppt/slides/slide20.xml><?xml version="1.0" encoding="utf-8"?>
-<p:sld xmlns:a="http://schemas.openxmlformats.org/drawingml/2006/main" xmlns:r="http://schemas.openxmlformats.org/officeDocument/2006/relationships" xmlns:p="http://schemas.openxmlformats.org/presentationml/2006/main" xmlns:m="http://schemas.openxmlformats.org/officeDocument/2006/math" xmlns:w="http://schemas.openxmlformats.org/wordprocessingml/2006/main" xmlns:mc="http://schemas.openxmlformats.org/markup-compatibility/2006" showMasterPhAnim="0" showMasterSp="1" show="1">
-  <p:cSld name="">
+<p:sld xmlns:a="http://schemas.openxmlformats.org/drawingml/2006/main" xmlns:r="http://schemas.openxmlformats.org/officeDocument/2006/relationships" xmlns:p="http://schemas.openxmlformats.org/presentationml/2006/main" showMasterPhAnim="0">
+  <p:cSld>
     <p:spTree>
       <p:nvGrpSpPr>
         <p:cNvPr id="1" name=""/>
@@ -21750,11 +21699,11 @@
   <p:clrMapOvr>
     <a:masterClrMapping/>
   </p:clrMapOvr>
-  <mc:AlternateContent xmlns:mc="http://schemas.openxmlformats.org/markup-compatibility/2006">
-    <mc:Choice xmlns:p159="http://schemas.microsoft.com/office/powerpoint/2015/09/main" xmlns:p14="http://schemas.microsoft.com/office/powerpoint/2010/main" Requires="p159">
-      <p:transition p14:dur="500" advClick="1"/>
+  <mc:AlternateContent xmlns:mc="http://schemas.openxmlformats.org/markup-compatibility/2006" xmlns:p159="http://schemas.microsoft.com/office/powerpoint/2015/09/main">
+    <mc:Choice Requires="p159">
+      <p:transition/>
     </mc:Choice>
-    <mc:Fallback>
+    <mc:Fallback xmlns:w="http://schemas.openxmlformats.org/wordprocessingml/2006/main" xmlns:m="http://schemas.openxmlformats.org/officeDocument/2006/math" xmlns="">
       <p:transition advClick="1"/>
     </mc:Fallback>
   </mc:AlternateContent>
@@ -21762,8 +21711,8 @@
 </file>
 
 <file path=ppt/slides/slide21.xml><?xml version="1.0" encoding="utf-8"?>
-<p:sld xmlns:a="http://schemas.openxmlformats.org/drawingml/2006/main" xmlns:r="http://schemas.openxmlformats.org/officeDocument/2006/relationships" xmlns:p="http://schemas.openxmlformats.org/presentationml/2006/main" xmlns:m="http://schemas.openxmlformats.org/officeDocument/2006/math" xmlns:w="http://schemas.openxmlformats.org/wordprocessingml/2006/main" xmlns:mc="http://schemas.openxmlformats.org/markup-compatibility/2006" showMasterPhAnim="0" showMasterSp="1" show="1">
-  <p:cSld name="">
+<p:sld xmlns:a="http://schemas.openxmlformats.org/drawingml/2006/main" xmlns:r="http://schemas.openxmlformats.org/officeDocument/2006/relationships" xmlns:p="http://schemas.openxmlformats.org/presentationml/2006/main" showMasterPhAnim="0">
+  <p:cSld>
     <p:spTree>
       <p:nvGrpSpPr>
         <p:cNvPr id="1" name=""/>
@@ -23184,11 +23133,11 @@
   <p:clrMapOvr>
     <a:masterClrMapping/>
   </p:clrMapOvr>
-  <mc:AlternateContent xmlns:mc="http://schemas.openxmlformats.org/markup-compatibility/2006">
-    <mc:Choice xmlns:p159="http://schemas.microsoft.com/office/powerpoint/2015/09/main" xmlns:p14="http://schemas.microsoft.com/office/powerpoint/2010/main" Requires="p159">
-      <p:transition p14:dur="500" advClick="1"/>
+  <mc:AlternateContent xmlns:mc="http://schemas.openxmlformats.org/markup-compatibility/2006" xmlns:p159="http://schemas.microsoft.com/office/powerpoint/2015/09/main">
+    <mc:Choice Requires="p159">
+      <p:transition/>
     </mc:Choice>
-    <mc:Fallback>
+    <mc:Fallback xmlns:w="http://schemas.openxmlformats.org/wordprocessingml/2006/main" xmlns:m="http://schemas.openxmlformats.org/officeDocument/2006/math" xmlns="">
       <p:transition advClick="1"/>
     </mc:Fallback>
   </mc:AlternateContent>
@@ -23196,8 +23145,8 @@
 </file>
 
 <file path=ppt/slides/slide22.xml><?xml version="1.0" encoding="utf-8"?>
-<p:sld xmlns:a="http://schemas.openxmlformats.org/drawingml/2006/main" xmlns:r="http://schemas.openxmlformats.org/officeDocument/2006/relationships" xmlns:p="http://schemas.openxmlformats.org/presentationml/2006/main" xmlns:m="http://schemas.openxmlformats.org/officeDocument/2006/math" xmlns:w="http://schemas.openxmlformats.org/wordprocessingml/2006/main" xmlns:mc="http://schemas.openxmlformats.org/markup-compatibility/2006" showMasterPhAnim="0" showMasterSp="1" show="1">
-  <p:cSld name="">
+<p:sld xmlns:a="http://schemas.openxmlformats.org/drawingml/2006/main" xmlns:r="http://schemas.openxmlformats.org/officeDocument/2006/relationships" xmlns:p="http://schemas.openxmlformats.org/presentationml/2006/main" showMasterPhAnim="0">
+  <p:cSld>
     <p:spTree>
       <p:nvGrpSpPr>
         <p:cNvPr id="1" name=""/>
@@ -23532,11 +23481,11 @@
   <p:clrMapOvr>
     <a:masterClrMapping/>
   </p:clrMapOvr>
-  <mc:AlternateContent xmlns:mc="http://schemas.openxmlformats.org/markup-compatibility/2006">
-    <mc:Choice xmlns:p159="http://schemas.microsoft.com/office/powerpoint/2015/09/main" xmlns:p14="http://schemas.microsoft.com/office/powerpoint/2010/main" Requires="p159">
-      <p:transition p14:dur="500" advClick="1"/>
+  <mc:AlternateContent xmlns:mc="http://schemas.openxmlformats.org/markup-compatibility/2006" xmlns:p159="http://schemas.microsoft.com/office/powerpoint/2015/09/main">
+    <mc:Choice Requires="p159">
+      <p:transition/>
     </mc:Choice>
-    <mc:Fallback>
+    <mc:Fallback xmlns:w="http://schemas.openxmlformats.org/wordprocessingml/2006/main" xmlns:m="http://schemas.openxmlformats.org/officeDocument/2006/math" xmlns="">
       <p:transition advClick="1"/>
     </mc:Fallback>
   </mc:AlternateContent>
@@ -23544,8 +23493,8 @@
 </file>
 
 <file path=ppt/slides/slide3.xml><?xml version="1.0" encoding="utf-8"?>
-<p:sld xmlns:a="http://schemas.openxmlformats.org/drawingml/2006/main" xmlns:r="http://schemas.openxmlformats.org/officeDocument/2006/relationships" xmlns:p="http://schemas.openxmlformats.org/presentationml/2006/main" xmlns:m="http://schemas.openxmlformats.org/officeDocument/2006/math" xmlns:w="http://schemas.openxmlformats.org/wordprocessingml/2006/main" xmlns:mc="http://schemas.openxmlformats.org/markup-compatibility/2006" showMasterPhAnim="0" showMasterSp="1" show="1">
-  <p:cSld name="">
+<p:sld xmlns:a="http://schemas.openxmlformats.org/drawingml/2006/main" xmlns:r="http://schemas.openxmlformats.org/officeDocument/2006/relationships" xmlns:p="http://schemas.openxmlformats.org/presentationml/2006/main" showMasterPhAnim="0">
+  <p:cSld>
     <p:spTree>
       <p:nvGrpSpPr>
         <p:cNvPr id="1" name=""/>
@@ -25523,11 +25472,11 @@
   <p:clrMapOvr>
     <a:masterClrMapping/>
   </p:clrMapOvr>
-  <mc:AlternateContent xmlns:mc="http://schemas.openxmlformats.org/markup-compatibility/2006">
-    <mc:Choice xmlns:p159="http://schemas.microsoft.com/office/powerpoint/2015/09/main" xmlns:p14="http://schemas.microsoft.com/office/powerpoint/2010/main" Requires="p159">
-      <p:transition p14:dur="500" advClick="1"/>
+  <mc:AlternateContent xmlns:mc="http://schemas.openxmlformats.org/markup-compatibility/2006" xmlns:p159="http://schemas.microsoft.com/office/powerpoint/2015/09/main">
+    <mc:Choice Requires="p159">
+      <p:transition/>
     </mc:Choice>
-    <mc:Fallback>
+    <mc:Fallback xmlns:w="http://schemas.openxmlformats.org/wordprocessingml/2006/main" xmlns:m="http://schemas.openxmlformats.org/officeDocument/2006/math" xmlns="">
       <p:transition advClick="1"/>
     </mc:Fallback>
   </mc:AlternateContent>
@@ -25535,8 +25484,8 @@
 </file>
 
 <file path=ppt/slides/slide4.xml><?xml version="1.0" encoding="utf-8"?>
-<p:sld xmlns:a="http://schemas.openxmlformats.org/drawingml/2006/main" xmlns:r="http://schemas.openxmlformats.org/officeDocument/2006/relationships" xmlns:p="http://schemas.openxmlformats.org/presentationml/2006/main" xmlns:m="http://schemas.openxmlformats.org/officeDocument/2006/math" xmlns:w="http://schemas.openxmlformats.org/wordprocessingml/2006/main" xmlns:mc="http://schemas.openxmlformats.org/markup-compatibility/2006" showMasterPhAnim="0" showMasterSp="1" show="1">
-  <p:cSld name="">
+<p:sld xmlns:a="http://schemas.openxmlformats.org/drawingml/2006/main" xmlns:r="http://schemas.openxmlformats.org/officeDocument/2006/relationships" xmlns:p="http://schemas.openxmlformats.org/presentationml/2006/main" showMasterPhAnim="0">
+  <p:cSld>
     <p:spTree>
       <p:nvGrpSpPr>
         <p:cNvPr id="1" name=""/>
@@ -28121,11 +28070,11 @@
   <p:clrMapOvr>
     <a:masterClrMapping/>
   </p:clrMapOvr>
-  <mc:AlternateContent xmlns:mc="http://schemas.openxmlformats.org/markup-compatibility/2006">
-    <mc:Choice xmlns:p159="http://schemas.microsoft.com/office/powerpoint/2015/09/main" xmlns:p14="http://schemas.microsoft.com/office/powerpoint/2010/main" Requires="p159">
-      <p:transition p14:dur="500" advClick="1"/>
+  <mc:AlternateContent xmlns:mc="http://schemas.openxmlformats.org/markup-compatibility/2006" xmlns:p159="http://schemas.microsoft.com/office/powerpoint/2015/09/main">
+    <mc:Choice Requires="p159">
+      <p:transition/>
     </mc:Choice>
-    <mc:Fallback>
+    <mc:Fallback xmlns:w="http://schemas.openxmlformats.org/wordprocessingml/2006/main" xmlns:m="http://schemas.openxmlformats.org/officeDocument/2006/math" xmlns="">
       <p:transition advClick="1"/>
     </mc:Fallback>
   </mc:AlternateContent>
@@ -28133,8 +28082,8 @@
 </file>
 
 <file path=ppt/slides/slide5.xml><?xml version="1.0" encoding="utf-8"?>
-<p:sld xmlns:a="http://schemas.openxmlformats.org/drawingml/2006/main" xmlns:r="http://schemas.openxmlformats.org/officeDocument/2006/relationships" xmlns:p="http://schemas.openxmlformats.org/presentationml/2006/main" xmlns:m="http://schemas.openxmlformats.org/officeDocument/2006/math" xmlns:w="http://schemas.openxmlformats.org/wordprocessingml/2006/main" xmlns:mc="http://schemas.openxmlformats.org/markup-compatibility/2006" showMasterPhAnim="0" showMasterSp="1" show="1">
-  <p:cSld name="">
+<p:sld xmlns:a="http://schemas.openxmlformats.org/drawingml/2006/main" xmlns:r="http://schemas.openxmlformats.org/officeDocument/2006/relationships" xmlns:p="http://schemas.openxmlformats.org/presentationml/2006/main" showMasterPhAnim="0">
+  <p:cSld>
     <p:spTree>
       <p:nvGrpSpPr>
         <p:cNvPr id="1" name=""/>
@@ -28202,7 +28151,7 @@
         <p:spPr bwMode="auto">
           <a:xfrm>
             <a:off x="566928" y="603504"/>
-            <a:ext cx="11058113" cy="475488"/>
+            <a:ext cx="11058113" cy="439864"/>
           </a:xfrm>
           <a:prstGeom prst="rect">
             <a:avLst/>
@@ -28215,25 +28164,40 @@
           </a:bodyPr>
           <a:lstStyle/>
           <a:p>
-            <a:pPr algn="l">
+            <a:pPr>
               <a:lnSpc>
                 <a:spcPct val="124000"/>
               </a:lnSpc>
-              <a:spcAft>
-                <a:spcPts val="0"/>
-              </a:spcAft>
-              <a:defRPr/>
-            </a:pPr>
-            <a:r>
-              <a:rPr sz="2500" b="1" i="0">
+              <a:defRPr/>
+            </a:pPr>
+            <a:r>
+              <a:rPr sz="2500" b="1" i="0" dirty="0">
                 <a:solidFill>
                   <a:srgbClr val="0B0B0B"/>
                 </a:solidFill>
                 <a:latin typeface="Segoe UI"/>
               </a:rPr>
-              <a:t>Steps 00–02 · Profiling, duplicates and missing values</a:t>
-            </a:r>
-            <a:endParaRPr/>
+              <a:t>Steps 00–02 · </a:t>
+            </a:r>
+            <a:r>
+              <a:rPr lang="en-US" sz="2500" b="1" dirty="0">
+                <a:solidFill>
+                  <a:srgbClr val="0B0B0B"/>
+                </a:solidFill>
+                <a:latin typeface="Segoe UI"/>
+              </a:rPr>
+              <a:t>Data exploration</a:t>
+            </a:r>
+            <a:r>
+              <a:rPr sz="2500" b="1" i="0" dirty="0">
+                <a:solidFill>
+                  <a:srgbClr val="0B0B0B"/>
+                </a:solidFill>
+                <a:latin typeface="Segoe UI"/>
+              </a:rPr>
+              <a:t>, duplicates and missing values</a:t>
+            </a:r>
+            <a:endParaRPr dirty="0"/>
           </a:p>
         </p:txBody>
       </p:sp>
@@ -29592,11 +29556,11 @@
   <p:clrMapOvr>
     <a:masterClrMapping/>
   </p:clrMapOvr>
-  <mc:AlternateContent xmlns:mc="http://schemas.openxmlformats.org/markup-compatibility/2006">
-    <mc:Choice xmlns:p159="http://schemas.microsoft.com/office/powerpoint/2015/09/main" xmlns:p14="http://schemas.microsoft.com/office/powerpoint/2010/main" Requires="p159">
-      <p:transition p14:dur="500" advClick="1"/>
+  <mc:AlternateContent xmlns:mc="http://schemas.openxmlformats.org/markup-compatibility/2006" xmlns:p159="http://schemas.microsoft.com/office/powerpoint/2015/09/main">
+    <mc:Choice Requires="p159">
+      <p:transition/>
     </mc:Choice>
-    <mc:Fallback>
+    <mc:Fallback xmlns:w="http://schemas.openxmlformats.org/wordprocessingml/2006/main" xmlns:m="http://schemas.openxmlformats.org/officeDocument/2006/math" xmlns="">
       <p:transition advClick="1"/>
     </mc:Fallback>
   </mc:AlternateContent>
@@ -29604,8 +29568,8 @@
 </file>
 
 <file path=ppt/slides/slide6.xml><?xml version="1.0" encoding="utf-8"?>
-<p:sld xmlns:a="http://schemas.openxmlformats.org/drawingml/2006/main" xmlns:r="http://schemas.openxmlformats.org/officeDocument/2006/relationships" xmlns:p="http://schemas.openxmlformats.org/presentationml/2006/main" xmlns:m="http://schemas.openxmlformats.org/officeDocument/2006/math" xmlns:w="http://schemas.openxmlformats.org/wordprocessingml/2006/main" xmlns:mc="http://schemas.openxmlformats.org/markup-compatibility/2006" showMasterPhAnim="0" showMasterSp="1" show="1">
-  <p:cSld name="">
+<p:sld xmlns:a="http://schemas.openxmlformats.org/drawingml/2006/main" xmlns:r="http://schemas.openxmlformats.org/officeDocument/2006/relationships" xmlns:p="http://schemas.openxmlformats.org/presentationml/2006/main" showMasterPhAnim="0">
+  <p:cSld>
     <p:spTree>
       <p:nvGrpSpPr>
         <p:cNvPr id="1" name=""/>
@@ -31105,11 +31069,11 @@
   <p:clrMapOvr>
     <a:masterClrMapping/>
   </p:clrMapOvr>
-  <mc:AlternateContent xmlns:mc="http://schemas.openxmlformats.org/markup-compatibility/2006">
-    <mc:Choice xmlns:p159="http://schemas.microsoft.com/office/powerpoint/2015/09/main" xmlns:p14="http://schemas.microsoft.com/office/powerpoint/2010/main" Requires="p159">
-      <p:transition p14:dur="500" advClick="1"/>
+  <mc:AlternateContent xmlns:mc="http://schemas.openxmlformats.org/markup-compatibility/2006" xmlns:p159="http://schemas.microsoft.com/office/powerpoint/2015/09/main">
+    <mc:Choice Requires="p159">
+      <p:transition/>
     </mc:Choice>
-    <mc:Fallback>
+    <mc:Fallback xmlns:w="http://schemas.openxmlformats.org/wordprocessingml/2006/main" xmlns:m="http://schemas.openxmlformats.org/officeDocument/2006/math" xmlns="">
       <p:transition advClick="1"/>
     </mc:Fallback>
   </mc:AlternateContent>
@@ -31117,8 +31081,8 @@
 </file>
 
 <file path=ppt/slides/slide7.xml><?xml version="1.0" encoding="utf-8"?>
-<p:sld xmlns:a="http://schemas.openxmlformats.org/drawingml/2006/main" xmlns:r="http://schemas.openxmlformats.org/officeDocument/2006/relationships" xmlns:p="http://schemas.openxmlformats.org/presentationml/2006/main" xmlns:m="http://schemas.openxmlformats.org/officeDocument/2006/math" xmlns:w="http://schemas.openxmlformats.org/wordprocessingml/2006/main" xmlns:mc="http://schemas.openxmlformats.org/markup-compatibility/2006" showMasterPhAnim="0" showMasterSp="1" show="1">
-  <p:cSld name="">
+<p:sld xmlns:a="http://schemas.openxmlformats.org/drawingml/2006/main" xmlns:r="http://schemas.openxmlformats.org/officeDocument/2006/relationships" xmlns:p="http://schemas.openxmlformats.org/presentationml/2006/main" showMasterPhAnim="0">
+  <p:cSld>
     <p:spTree>
       <p:nvGrpSpPr>
         <p:cNvPr id="1" name=""/>
@@ -32100,11 +32064,11 @@
   <p:clrMapOvr>
     <a:masterClrMapping/>
   </p:clrMapOvr>
-  <mc:AlternateContent xmlns:mc="http://schemas.openxmlformats.org/markup-compatibility/2006">
-    <mc:Choice xmlns:p159="http://schemas.microsoft.com/office/powerpoint/2015/09/main" xmlns:p14="http://schemas.microsoft.com/office/powerpoint/2010/main" Requires="p159">
-      <p:transition p14:dur="500" advClick="1"/>
+  <mc:AlternateContent xmlns:mc="http://schemas.openxmlformats.org/markup-compatibility/2006" xmlns:p159="http://schemas.microsoft.com/office/powerpoint/2015/09/main">
+    <mc:Choice Requires="p159">
+      <p:transition/>
     </mc:Choice>
-    <mc:Fallback>
+    <mc:Fallback xmlns:w="http://schemas.openxmlformats.org/wordprocessingml/2006/main" xmlns:m="http://schemas.openxmlformats.org/officeDocument/2006/math" xmlns="">
       <p:transition advClick="1"/>
     </mc:Fallback>
   </mc:AlternateContent>
@@ -32112,8 +32076,8 @@
 </file>
 
 <file path=ppt/slides/slide8.xml><?xml version="1.0" encoding="utf-8"?>
-<p:sld xmlns:a="http://schemas.openxmlformats.org/drawingml/2006/main" xmlns:r="http://schemas.openxmlformats.org/officeDocument/2006/relationships" xmlns:p="http://schemas.openxmlformats.org/presentationml/2006/main" xmlns:m="http://schemas.openxmlformats.org/officeDocument/2006/math" xmlns:w="http://schemas.openxmlformats.org/wordprocessingml/2006/main" xmlns:mc="http://schemas.openxmlformats.org/markup-compatibility/2006" showMasterPhAnim="0" showMasterSp="1" show="1">
-  <p:cSld name="">
+<p:sld xmlns:a="http://schemas.openxmlformats.org/drawingml/2006/main" xmlns:r="http://schemas.openxmlformats.org/officeDocument/2006/relationships" xmlns:p="http://schemas.openxmlformats.org/presentationml/2006/main" showMasterPhAnim="0">
+  <p:cSld>
     <p:spTree>
       <p:nvGrpSpPr>
         <p:cNvPr id="1" name=""/>
@@ -32855,11 +32819,11 @@
   <p:clrMapOvr>
     <a:masterClrMapping/>
   </p:clrMapOvr>
-  <mc:AlternateContent xmlns:mc="http://schemas.openxmlformats.org/markup-compatibility/2006">
-    <mc:Choice xmlns:p159="http://schemas.microsoft.com/office/powerpoint/2015/09/main" xmlns:p14="http://schemas.microsoft.com/office/powerpoint/2010/main" Requires="p159">
-      <p:transition p14:dur="500" advClick="1"/>
+  <mc:AlternateContent xmlns:mc="http://schemas.openxmlformats.org/markup-compatibility/2006" xmlns:p159="http://schemas.microsoft.com/office/powerpoint/2015/09/main">
+    <mc:Choice Requires="p159">
+      <p:transition/>
     </mc:Choice>
-    <mc:Fallback>
+    <mc:Fallback xmlns:w="http://schemas.openxmlformats.org/wordprocessingml/2006/main" xmlns:m="http://schemas.openxmlformats.org/officeDocument/2006/math" xmlns="">
       <p:transition advClick="1"/>
     </mc:Fallback>
   </mc:AlternateContent>
@@ -32867,8 +32831,8 @@
 </file>
 
 <file path=ppt/slides/slide9.xml><?xml version="1.0" encoding="utf-8"?>
-<p:sld xmlns:a="http://schemas.openxmlformats.org/drawingml/2006/main" xmlns:r="http://schemas.openxmlformats.org/officeDocument/2006/relationships" xmlns:p="http://schemas.openxmlformats.org/presentationml/2006/main" xmlns:m="http://schemas.openxmlformats.org/officeDocument/2006/math" xmlns:w="http://schemas.openxmlformats.org/wordprocessingml/2006/main" xmlns:mc="http://schemas.openxmlformats.org/markup-compatibility/2006" showMasterPhAnim="0" showMasterSp="1" show="1">
-  <p:cSld name="">
+<p:sld xmlns:a="http://schemas.openxmlformats.org/drawingml/2006/main" xmlns:r="http://schemas.openxmlformats.org/officeDocument/2006/relationships" xmlns:p="http://schemas.openxmlformats.org/presentationml/2006/main" showMasterPhAnim="0">
+  <p:cSld>
     <p:spTree>
       <p:nvGrpSpPr>
         <p:cNvPr id="1" name=""/>
@@ -33315,8 +33279,8 @@
         </p:nvSpPr>
         <p:spPr bwMode="auto">
           <a:xfrm>
-            <a:off x="566928" y="4773168"/>
-            <a:ext cx="5401040" cy="1371600"/>
+            <a:off x="594142" y="4891096"/>
+            <a:ext cx="5373826" cy="1253672"/>
           </a:xfrm>
           <a:prstGeom prst="rect">
             <a:avLst/>
@@ -33361,9 +33325,9 @@
           <p:nvPr/>
         </p:nvSpPr>
         <p:spPr bwMode="auto">
-          <a:xfrm>
-            <a:off x="566928" y="4773168"/>
-            <a:ext cx="41148" cy="1371600"/>
+          <a:xfrm flipH="1">
+            <a:off x="589934" y="4891096"/>
+            <a:ext cx="4208" cy="1253672"/>
           </a:xfrm>
           <a:prstGeom prst="rect">
             <a:avLst/>
@@ -33497,8 +33461,8 @@
         </p:nvSpPr>
         <p:spPr bwMode="auto">
           <a:xfrm>
-            <a:off x="6224000" y="4773168"/>
-            <a:ext cx="5401040" cy="1371600"/>
+            <a:off x="6251214" y="4891096"/>
+            <a:ext cx="5373826" cy="1253672"/>
           </a:xfrm>
           <a:prstGeom prst="rect">
             <a:avLst/>
@@ -33543,9 +33507,9 @@
           <p:nvPr/>
         </p:nvSpPr>
         <p:spPr bwMode="auto">
-          <a:xfrm>
-            <a:off x="6224000" y="4773168"/>
-            <a:ext cx="41148" cy="1371600"/>
+          <a:xfrm flipH="1">
+            <a:off x="6247006" y="4891096"/>
+            <a:ext cx="4208" cy="1253672"/>
           </a:xfrm>
           <a:prstGeom prst="rect">
             <a:avLst/>
@@ -33811,11 +33775,11 @@
   <p:clrMapOvr>
     <a:masterClrMapping/>
   </p:clrMapOvr>
-  <mc:AlternateContent xmlns:mc="http://schemas.openxmlformats.org/markup-compatibility/2006">
-    <mc:Choice xmlns:p159="http://schemas.microsoft.com/office/powerpoint/2015/09/main" xmlns:p14="http://schemas.microsoft.com/office/powerpoint/2010/main" Requires="p159">
-      <p:transition p14:dur="500" advClick="1"/>
+  <mc:AlternateContent xmlns:mc="http://schemas.openxmlformats.org/markup-compatibility/2006" xmlns:p159="http://schemas.microsoft.com/office/powerpoint/2015/09/main">
+    <mc:Choice Requires="p159">
+      <p:transition/>
     </mc:Choice>
-    <mc:Fallback>
+    <mc:Fallback xmlns:w="http://schemas.openxmlformats.org/wordprocessingml/2006/main" xmlns:m="http://schemas.openxmlformats.org/officeDocument/2006/math" xmlns="">
       <p:transition advClick="1"/>
     </mc:Fallback>
   </mc:AlternateContent>
@@ -33823,7 +33787,7 @@
 </file>
 
 <file path=ppt/theme/theme1.xml><?xml version="1.0" encoding="utf-8"?>
-<a:theme xmlns:a="http://schemas.openxmlformats.org/drawingml/2006/main" xmlns:r="http://schemas.openxmlformats.org/officeDocument/2006/relationships" xmlns:p="http://schemas.openxmlformats.org/presentationml/2006/main" name="Office Theme">
+<a:theme xmlns:a="http://schemas.openxmlformats.org/drawingml/2006/main" name="Office Theme">
   <a:themeElements>
     <a:clrScheme name="Office">
       <a:dk1>
@@ -34074,11 +34038,12 @@
       </a:style>
     </a:lnDef>
   </a:objectDefaults>
+  <a:extraClrSchemeLst/>
 </a:theme>
 </file>
 
 <file path=ppt/theme/theme2.xml><?xml version="1.0" encoding="utf-8"?>
-<a:theme xmlns:a="http://schemas.openxmlformats.org/drawingml/2006/main" xmlns:r="http://schemas.openxmlformats.org/officeDocument/2006/relationships" xmlns:p="http://schemas.openxmlformats.org/presentationml/2006/main" name="Office Theme">
+<a:theme xmlns:a="http://schemas.openxmlformats.org/drawingml/2006/main" name="Office Theme">
   <a:themeElements>
     <a:clrScheme name="Office">
       <a:dk1>
@@ -34289,5 +34254,6 @@
       </a:style>
     </a:lnDef>
   </a:objectDefaults>
+  <a:extraClrSchemeLst/>
 </a:theme>
 </file>
</xml_diff>